<commit_message>
docs(slides): apply visual theme and frame alignment fixes
</commit_message>
<xml_diff>
--- a/docs/ctg_benchmark_presentation.pptx
+++ b/docs/ctg_benchmark_presentation.pptx
@@ -511,7 +511,7 @@
           <a:lstStyle/>
           <a:p>
             <a:r>
-              <a:t>Good [morning/afternoon]. I am Naem Haq, and this presentation summarizes my FYP benchmarking study on machine-learning classifiers for CTG fetal heart rate pattern detection. The work is framed by my Residency 4 context at INFANT Research Centre, and focuses on fair, reproducible model comparison for decision-support relevance.</a:t>
+              <a:t>Hi, I’m Naem Haq. This final year project benchmarks machine-learning classifiers for fetal heart rate pattern detection in Cardiotocography, CTG for short. The work was shaped during my 4th Residency at INFANT Research Centre, where interpretation variability in labour monitoring highlighted the need for controlled, reproducible evaluation.</a:t>
             </a:r>
           </a:p>
         </p:txBody>
@@ -581,7 +581,7 @@
           <a:lstStyle/>
           <a:p>
             <a:r>
-              <a:t>Findings are bounded to CTU-UHB and weak labels, and inferential repeated-resampling analysis was not executed in this benchmark cycle. Priority extensions are stronger uncertainty analysis and external validation on broader datasets. This is the pathway toward prospective clinician-facing translation, aligned with INFANT and AI4Life goals.</a:t>
+              <a:t>These findings are specific to the CTU-UHB cohort and weak-label setting used in this benchmark. Next steps are uncertainty-focused repeat evaluation and external validation on broader datasets to support prospective clinician-facing translation in INFANT/AI4Life contexts.</a:t>
             </a:r>
           </a:p>
         </p:txBody>
@@ -4140,6 +4140,14 @@
 <file path=ppt/slides/slide1.xml><?xml version="1.0" encoding="utf-8"?>
 <p:sld xmlns:a="http://schemas.openxmlformats.org/drawingml/2006/main" xmlns:p="http://schemas.openxmlformats.org/presentationml/2006/main" xmlns:r="http://schemas.openxmlformats.org/officeDocument/2006/relationships">
   <p:cSld>
+    <p:bg>
+      <p:bgPr>
+        <a:solidFill>
+          <a:srgbClr val="0B1020"/>
+        </a:solidFill>
+        <a:effectLst/>
+      </p:bgPr>
+    </p:bg>
     <p:spTree>
       <p:nvGrpSpPr>
         <p:cNvPr id="1" name=""/>
@@ -4149,6 +4157,135 @@
       <p:grpSpPr/>
       <p:sp>
         <p:nvSpPr>
+          <p:cNvPr id="6" name="Rectangle 5"/>
+          <p:cNvSpPr/>
+          <p:nvPr/>
+        </p:nvSpPr>
+        <p:spPr>
+          <a:xfrm>
+            <a:off x="0" y="0"/>
+            <a:ext cx="12188952" cy="109728"/>
+          </a:xfrm>
+          <a:prstGeom prst="rect">
+            <a:avLst/>
+          </a:prstGeom>
+          <a:solidFill>
+            <a:srgbClr val="3EB7DB"/>
+          </a:solidFill>
+          <a:ln>
+            <a:noFill/>
+          </a:ln>
+        </p:spPr>
+        <p:style>
+          <a:lnRef idx="1">
+            <a:schemeClr val="accent1"/>
+          </a:lnRef>
+          <a:fillRef idx="3">
+            <a:schemeClr val="accent1"/>
+          </a:fillRef>
+          <a:effectRef idx="2">
+            <a:schemeClr val="accent1"/>
+          </a:effectRef>
+          <a:fontRef idx="minor">
+            <a:schemeClr val="lt1"/>
+          </a:fontRef>
+        </p:style>
+        <p:txBody>
+          <a:bodyPr rtlCol="0" anchor="ctr"/>
+          <a:lstStyle/>
+          <a:p>
+            <a:pPr algn="ctr"/>
+          </a:p>
+        </p:txBody>
+      </p:sp>
+      <p:sp>
+        <p:nvSpPr>
+          <p:cNvPr id="5" name="Oval 4"/>
+          <p:cNvSpPr/>
+          <p:nvPr/>
+        </p:nvSpPr>
+        <p:spPr>
+          <a:xfrm>
+            <a:off x="7772400" y="4389120"/>
+            <a:ext cx="3657600" cy="3657600"/>
+          </a:xfrm>
+          <a:prstGeom prst="ellipse">
+            <a:avLst/>
+          </a:prstGeom>
+          <a:solidFill>
+            <a:srgbClr val="3EB7DB"/>
+          </a:solidFill>
+          <a:ln>
+            <a:noFill/>
+          </a:ln>
+        </p:spPr>
+        <p:style>
+          <a:lnRef idx="1">
+            <a:schemeClr val="accent1"/>
+          </a:lnRef>
+          <a:fillRef idx="3">
+            <a:schemeClr val="accent1"/>
+          </a:fillRef>
+          <a:effectRef idx="2">
+            <a:schemeClr val="accent1"/>
+          </a:effectRef>
+          <a:fontRef idx="minor">
+            <a:schemeClr val="lt1"/>
+          </a:fontRef>
+        </p:style>
+        <p:txBody>
+          <a:bodyPr rtlCol="0" anchor="ctr"/>
+          <a:lstStyle/>
+          <a:p>
+            <a:pPr algn="ctr"/>
+          </a:p>
+        </p:txBody>
+      </p:sp>
+      <p:sp>
+        <p:nvSpPr>
+          <p:cNvPr id="4" name="Oval 3"/>
+          <p:cNvSpPr/>
+          <p:nvPr/>
+        </p:nvSpPr>
+        <p:spPr>
+          <a:xfrm>
+            <a:off x="-1097280" y="-914400"/>
+            <a:ext cx="3657600" cy="3657600"/>
+          </a:xfrm>
+          <a:prstGeom prst="ellipse">
+            <a:avLst/>
+          </a:prstGeom>
+          <a:solidFill>
+            <a:srgbClr val="336DD9"/>
+          </a:solidFill>
+          <a:ln>
+            <a:noFill/>
+          </a:ln>
+        </p:spPr>
+        <p:style>
+          <a:lnRef idx="1">
+            <a:schemeClr val="accent1"/>
+          </a:lnRef>
+          <a:fillRef idx="3">
+            <a:schemeClr val="accent1"/>
+          </a:fillRef>
+          <a:effectRef idx="2">
+            <a:schemeClr val="accent1"/>
+          </a:effectRef>
+          <a:fontRef idx="minor">
+            <a:schemeClr val="lt1"/>
+          </a:fontRef>
+        </p:style>
+        <p:txBody>
+          <a:bodyPr rtlCol="0" anchor="ctr"/>
+          <a:lstStyle/>
+          <a:p>
+            <a:pPr algn="ctr"/>
+          </a:p>
+        </p:txBody>
+      </p:sp>
+      <p:sp>
+        <p:nvSpPr>
           <p:cNvPr id="2" name="Title 1"/>
           <p:cNvSpPr>
             <a:spLocks noGrp="1"/>
@@ -4163,9 +4300,20 @@
           <a:lstStyle/>
           <a:p>
             <a:pPr>
-              <a:defRPr sz="3600"/>
+              <a:defRPr sz="4000" b="1">
+                <a:solidFill>
+                  <a:srgbClr val="ECF1FF"/>
+                </a:solidFill>
+                <a:latin typeface="Calibri"/>
+              </a:defRPr>
             </a:pPr>
             <a:r>
+              <a:rPr sz="4000" b="1">
+                <a:solidFill>
+                  <a:srgbClr val="ECF1FF"/>
+                </a:solidFill>
+                <a:latin typeface="Calibri"/>
+              </a:rPr>
               <a:t>Benchmarking ML Classifiers for CTG</a:t>
             </a:r>
           </a:p>
@@ -4192,26 +4340,112 @@
           <a:lstStyle/>
           <a:p>
             <a:pPr>
-              <a:defRPr sz="1800"/>
+              <a:defRPr sz="1800" b="0">
+                <a:solidFill>
+                  <a:srgbClr val="B9C4E2"/>
+                </a:solidFill>
+                <a:latin typeface="Calibri"/>
+              </a:defRPr>
             </a:pPr>
             <a:r>
+              <a:rPr sz="1800" b="0">
+                <a:solidFill>
+                  <a:srgbClr val="B9C4E2"/>
+                </a:solidFill>
+                <a:latin typeface="Calibri"/>
+              </a:rPr>
               <a:t>Naem Haq</a:t>
             </a:r>
           </a:p>
           <a:p>
             <a:pPr>
-              <a:defRPr sz="1800"/>
+              <a:defRPr sz="1800" b="0">
+                <a:solidFill>
+                  <a:srgbClr val="B9C4E2"/>
+                </a:solidFill>
+                <a:latin typeface="Calibri"/>
+              </a:defRPr>
             </a:pPr>
             <a:r>
+              <a:rPr sz="1800" b="0">
+                <a:solidFill>
+                  <a:srgbClr val="B9C4E2"/>
+                </a:solidFill>
+                <a:latin typeface="Calibri"/>
+              </a:rPr>
               <a:t>FYP Dissertation Presentation</a:t>
             </a:r>
           </a:p>
           <a:p>
             <a:pPr>
-              <a:defRPr sz="1800"/>
+              <a:defRPr sz="1800" b="0">
+                <a:solidFill>
+                  <a:srgbClr val="B9C4E2"/>
+                </a:solidFill>
+                <a:latin typeface="Calibri"/>
+              </a:defRPr>
             </a:pPr>
             <a:r>
+              <a:rPr sz="1800" b="0">
+                <a:solidFill>
+                  <a:srgbClr val="B9C4E2"/>
+                </a:solidFill>
+                <a:latin typeface="Calibri"/>
+              </a:rPr>
               <a:t>Residency 4 context: INFANT Research Centre (UCC)</a:t>
+            </a:r>
+          </a:p>
+        </p:txBody>
+      </p:sp>
+      <p:sp>
+        <p:nvSpPr>
+          <p:cNvPr id="7" name="Rounded Rectangle 6"/>
+          <p:cNvSpPr/>
+          <p:nvPr/>
+        </p:nvSpPr>
+        <p:spPr>
+          <a:xfrm>
+            <a:off x="822960" y="5440680"/>
+            <a:ext cx="3840480" cy="502920"/>
+          </a:xfrm>
+          <a:prstGeom prst="roundRect">
+            <a:avLst/>
+          </a:prstGeom>
+          <a:solidFill>
+            <a:srgbClr val="336DD9"/>
+          </a:solidFill>
+          <a:ln>
+            <a:noFill/>
+          </a:ln>
+        </p:spPr>
+        <p:style>
+          <a:lnRef idx="1">
+            <a:schemeClr val="accent1"/>
+          </a:lnRef>
+          <a:fillRef idx="3">
+            <a:schemeClr val="accent1"/>
+          </a:fillRef>
+          <a:effectRef idx="2">
+            <a:schemeClr val="accent1"/>
+          </a:effectRef>
+          <a:fontRef idx="minor">
+            <a:schemeClr val="lt1"/>
+          </a:fontRef>
+        </p:style>
+        <p:txBody>
+          <a:bodyPr rtlCol="0" anchor="ctr"/>
+          <a:lstStyle/>
+          <a:p>
+            <a:pPr algn="ctr">
+              <a:defRPr sz="1200">
+                <a:solidFill>
+                  <a:srgbClr val="ECF1FF"/>
+                </a:solidFill>
+                <a:latin typeface="Calibri"/>
+              </a:defRPr>
+            </a:pPr>
+            <a:r>
+              <a:t>CTU-UHB • RF vs 1D-CNN • Reproducible Benchmark</a:t>
             </a:r>
           </a:p>
         </p:txBody>
@@ -4227,6 +4461,14 @@
 <file path=ppt/slides/slide10.xml><?xml version="1.0" encoding="utf-8"?>
 <p:sld xmlns:a="http://schemas.openxmlformats.org/drawingml/2006/main" xmlns:p="http://schemas.openxmlformats.org/presentationml/2006/main" xmlns:r="http://schemas.openxmlformats.org/officeDocument/2006/relationships">
   <p:cSld>
+    <p:bg>
+      <p:bgPr>
+        <a:solidFill>
+          <a:srgbClr val="0B1020"/>
+        </a:solidFill>
+        <a:effectLst/>
+      </p:bgPr>
+    </p:bg>
     <p:spTree>
       <p:nvGrpSpPr>
         <p:cNvPr id="1" name=""/>
@@ -4236,6 +4478,135 @@
       <p:grpSpPr/>
       <p:sp>
         <p:nvSpPr>
+          <p:cNvPr id="6" name="Rectangle 5"/>
+          <p:cNvSpPr/>
+          <p:nvPr/>
+        </p:nvSpPr>
+        <p:spPr>
+          <a:xfrm>
+            <a:off x="0" y="0"/>
+            <a:ext cx="12188952" cy="109728"/>
+          </a:xfrm>
+          <a:prstGeom prst="rect">
+            <a:avLst/>
+          </a:prstGeom>
+          <a:solidFill>
+            <a:srgbClr val="3EB7DB"/>
+          </a:solidFill>
+          <a:ln>
+            <a:noFill/>
+          </a:ln>
+        </p:spPr>
+        <p:style>
+          <a:lnRef idx="1">
+            <a:schemeClr val="accent1"/>
+          </a:lnRef>
+          <a:fillRef idx="3">
+            <a:schemeClr val="accent1"/>
+          </a:fillRef>
+          <a:effectRef idx="2">
+            <a:schemeClr val="accent1"/>
+          </a:effectRef>
+          <a:fontRef idx="minor">
+            <a:schemeClr val="lt1"/>
+          </a:fontRef>
+        </p:style>
+        <p:txBody>
+          <a:bodyPr rtlCol="0" anchor="ctr"/>
+          <a:lstStyle/>
+          <a:p>
+            <a:pPr algn="ctr"/>
+          </a:p>
+        </p:txBody>
+      </p:sp>
+      <p:sp>
+        <p:nvSpPr>
+          <p:cNvPr id="5" name="Oval 4"/>
+          <p:cNvSpPr/>
+          <p:nvPr/>
+        </p:nvSpPr>
+        <p:spPr>
+          <a:xfrm>
+            <a:off x="7772400" y="4389120"/>
+            <a:ext cx="3657600" cy="3657600"/>
+          </a:xfrm>
+          <a:prstGeom prst="ellipse">
+            <a:avLst/>
+          </a:prstGeom>
+          <a:solidFill>
+            <a:srgbClr val="3EB7DB"/>
+          </a:solidFill>
+          <a:ln>
+            <a:noFill/>
+          </a:ln>
+        </p:spPr>
+        <p:style>
+          <a:lnRef idx="1">
+            <a:schemeClr val="accent1"/>
+          </a:lnRef>
+          <a:fillRef idx="3">
+            <a:schemeClr val="accent1"/>
+          </a:fillRef>
+          <a:effectRef idx="2">
+            <a:schemeClr val="accent1"/>
+          </a:effectRef>
+          <a:fontRef idx="minor">
+            <a:schemeClr val="lt1"/>
+          </a:fontRef>
+        </p:style>
+        <p:txBody>
+          <a:bodyPr rtlCol="0" anchor="ctr"/>
+          <a:lstStyle/>
+          <a:p>
+            <a:pPr algn="ctr"/>
+          </a:p>
+        </p:txBody>
+      </p:sp>
+      <p:sp>
+        <p:nvSpPr>
+          <p:cNvPr id="4" name="Oval 3"/>
+          <p:cNvSpPr/>
+          <p:nvPr/>
+        </p:nvSpPr>
+        <p:spPr>
+          <a:xfrm>
+            <a:off x="-1097280" y="-914400"/>
+            <a:ext cx="3657600" cy="3657600"/>
+          </a:xfrm>
+          <a:prstGeom prst="ellipse">
+            <a:avLst/>
+          </a:prstGeom>
+          <a:solidFill>
+            <a:srgbClr val="336DD9"/>
+          </a:solidFill>
+          <a:ln>
+            <a:noFill/>
+          </a:ln>
+        </p:spPr>
+        <p:style>
+          <a:lnRef idx="1">
+            <a:schemeClr val="accent1"/>
+          </a:lnRef>
+          <a:fillRef idx="3">
+            <a:schemeClr val="accent1"/>
+          </a:fillRef>
+          <a:effectRef idx="2">
+            <a:schemeClr val="accent1"/>
+          </a:effectRef>
+          <a:fontRef idx="minor">
+            <a:schemeClr val="lt1"/>
+          </a:fontRef>
+        </p:style>
+        <p:txBody>
+          <a:bodyPr rtlCol="0" anchor="ctr"/>
+          <a:lstStyle/>
+          <a:p>
+            <a:pPr algn="ctr"/>
+          </a:p>
+        </p:txBody>
+      </p:sp>
+      <p:sp>
+        <p:nvSpPr>
           <p:cNvPr id="2" name="Title 1"/>
           <p:cNvSpPr>
             <a:spLocks noGrp="1"/>
@@ -4250,9 +4621,20 @@
           <a:lstStyle/>
           <a:p>
             <a:pPr>
-              <a:defRPr sz="3400"/>
+              <a:defRPr sz="3400" b="1">
+                <a:solidFill>
+                  <a:srgbClr val="ECF1FF"/>
+                </a:solidFill>
+                <a:latin typeface="Calibri"/>
+              </a:defRPr>
             </a:pPr>
             <a:r>
+              <a:rPr sz="3400" b="1">
+                <a:solidFill>
+                  <a:srgbClr val="ECF1FF"/>
+                </a:solidFill>
+                <a:latin typeface="Calibri"/>
+              </a:rPr>
               <a:t>Limitations and Next Steps</a:t>
             </a:r>
           </a:p>
@@ -4274,35 +4656,122 @@
           <a:lstStyle/>
           <a:p>
             <a:pPr>
-              <a:defRPr sz="2000"/>
+              <a:defRPr sz="2000" b="0">
+                <a:solidFill>
+                  <a:srgbClr val="ECF1FF"/>
+                </a:solidFill>
+                <a:latin typeface="Calibri"/>
+              </a:defRPr>
             </a:pPr>
             <a:r>
+              <a:rPr sz="2000" b="0">
+                <a:solidFill>
+                  <a:srgbClr val="ECF1FF"/>
+                </a:solidFill>
+                <a:latin typeface="Calibri"/>
+              </a:rPr>
               <a:t>Findings are bounded to CTU-UHB and weak-label regime.</a:t>
             </a:r>
           </a:p>
           <a:p>
             <a:pPr>
-              <a:defRPr sz="2000"/>
+              <a:defRPr sz="2000" b="0">
+                <a:solidFill>
+                  <a:srgbClr val="ECF1FF"/>
+                </a:solidFill>
+                <a:latin typeface="Calibri"/>
+              </a:defRPr>
             </a:pPr>
             <a:r>
+              <a:rPr sz="2000" b="0">
+                <a:solidFill>
+                  <a:srgbClr val="ECF1FF"/>
+                </a:solidFill>
+                <a:latin typeface="Calibri"/>
+              </a:rPr>
               <a:t>Repeated grouped resampling and stronger uncertainty quantification are future extensions.</a:t>
             </a:r>
           </a:p>
           <a:p>
             <a:pPr>
-              <a:defRPr sz="2000"/>
+              <a:defRPr sz="2000" b="0">
+                <a:solidFill>
+                  <a:srgbClr val="ECF1FF"/>
+                </a:solidFill>
+                <a:latin typeface="Calibri"/>
+              </a:defRPr>
             </a:pPr>
             <a:r>
+              <a:rPr sz="2000" b="0">
+                <a:solidFill>
+                  <a:srgbClr val="ECF1FF"/>
+                </a:solidFill>
+                <a:latin typeface="Calibri"/>
+              </a:rPr>
               <a:t>External validation across broader datasets is required for stronger transportability claims.</a:t>
             </a:r>
           </a:p>
           <a:p>
             <a:pPr>
-              <a:defRPr sz="2000"/>
+              <a:defRPr sz="2000" b="0">
+                <a:solidFill>
+                  <a:srgbClr val="ECF1FF"/>
+                </a:solidFill>
+                <a:latin typeface="Calibri"/>
+              </a:defRPr>
             </a:pPr>
             <a:r>
+              <a:rPr sz="2000" b="0">
+                <a:solidFill>
+                  <a:srgbClr val="ECF1FF"/>
+                </a:solidFill>
+                <a:latin typeface="Calibri"/>
+              </a:rPr>
               <a:t>Pathway: prospective, clinician-facing translation aligned with INFANT/AI4Life goals.</a:t>
             </a:r>
+          </a:p>
+        </p:txBody>
+      </p:sp>
+      <p:sp>
+        <p:nvSpPr>
+          <p:cNvPr id="7" name="Rectangle 6"/>
+          <p:cNvSpPr/>
+          <p:nvPr/>
+        </p:nvSpPr>
+        <p:spPr>
+          <a:xfrm>
+            <a:off x="822960" y="1234440"/>
+            <a:ext cx="2011680" cy="45720"/>
+          </a:xfrm>
+          <a:prstGeom prst="rect">
+            <a:avLst/>
+          </a:prstGeom>
+          <a:solidFill>
+            <a:srgbClr val="3EB7DB"/>
+          </a:solidFill>
+          <a:ln>
+            <a:noFill/>
+          </a:ln>
+        </p:spPr>
+        <p:style>
+          <a:lnRef idx="1">
+            <a:schemeClr val="accent1"/>
+          </a:lnRef>
+          <a:fillRef idx="3">
+            <a:schemeClr val="accent1"/>
+          </a:fillRef>
+          <a:effectRef idx="2">
+            <a:schemeClr val="accent1"/>
+          </a:effectRef>
+          <a:fontRef idx="minor">
+            <a:schemeClr val="lt1"/>
+          </a:fontRef>
+        </p:style>
+        <p:txBody>
+          <a:bodyPr rtlCol="0" anchor="ctr"/>
+          <a:lstStyle/>
+          <a:p>
+            <a:pPr algn="ctr"/>
           </a:p>
         </p:txBody>
       </p:sp>
@@ -4317,6 +4786,14 @@
 <file path=ppt/slides/slide2.xml><?xml version="1.0" encoding="utf-8"?>
 <p:sld xmlns:a="http://schemas.openxmlformats.org/drawingml/2006/main" xmlns:p="http://schemas.openxmlformats.org/presentationml/2006/main" xmlns:r="http://schemas.openxmlformats.org/officeDocument/2006/relationships">
   <p:cSld>
+    <p:bg>
+      <p:bgPr>
+        <a:solidFill>
+          <a:srgbClr val="0B1020"/>
+        </a:solidFill>
+        <a:effectLst/>
+      </p:bgPr>
+    </p:bg>
     <p:spTree>
       <p:nvGrpSpPr>
         <p:cNvPr id="1" name=""/>
@@ -4326,6 +4803,135 @@
       <p:grpSpPr/>
       <p:sp>
         <p:nvSpPr>
+          <p:cNvPr id="6" name="Rectangle 5"/>
+          <p:cNvSpPr/>
+          <p:nvPr/>
+        </p:nvSpPr>
+        <p:spPr>
+          <a:xfrm>
+            <a:off x="0" y="0"/>
+            <a:ext cx="12188952" cy="109728"/>
+          </a:xfrm>
+          <a:prstGeom prst="rect">
+            <a:avLst/>
+          </a:prstGeom>
+          <a:solidFill>
+            <a:srgbClr val="3EB7DB"/>
+          </a:solidFill>
+          <a:ln>
+            <a:noFill/>
+          </a:ln>
+        </p:spPr>
+        <p:style>
+          <a:lnRef idx="1">
+            <a:schemeClr val="accent1"/>
+          </a:lnRef>
+          <a:fillRef idx="3">
+            <a:schemeClr val="accent1"/>
+          </a:fillRef>
+          <a:effectRef idx="2">
+            <a:schemeClr val="accent1"/>
+          </a:effectRef>
+          <a:fontRef idx="minor">
+            <a:schemeClr val="lt1"/>
+          </a:fontRef>
+        </p:style>
+        <p:txBody>
+          <a:bodyPr rtlCol="0" anchor="ctr"/>
+          <a:lstStyle/>
+          <a:p>
+            <a:pPr algn="ctr"/>
+          </a:p>
+        </p:txBody>
+      </p:sp>
+      <p:sp>
+        <p:nvSpPr>
+          <p:cNvPr id="5" name="Oval 4"/>
+          <p:cNvSpPr/>
+          <p:nvPr/>
+        </p:nvSpPr>
+        <p:spPr>
+          <a:xfrm>
+            <a:off x="7772400" y="4389120"/>
+            <a:ext cx="3657600" cy="3657600"/>
+          </a:xfrm>
+          <a:prstGeom prst="ellipse">
+            <a:avLst/>
+          </a:prstGeom>
+          <a:solidFill>
+            <a:srgbClr val="3EB7DB"/>
+          </a:solidFill>
+          <a:ln>
+            <a:noFill/>
+          </a:ln>
+        </p:spPr>
+        <p:style>
+          <a:lnRef idx="1">
+            <a:schemeClr val="accent1"/>
+          </a:lnRef>
+          <a:fillRef idx="3">
+            <a:schemeClr val="accent1"/>
+          </a:fillRef>
+          <a:effectRef idx="2">
+            <a:schemeClr val="accent1"/>
+          </a:effectRef>
+          <a:fontRef idx="minor">
+            <a:schemeClr val="lt1"/>
+          </a:fontRef>
+        </p:style>
+        <p:txBody>
+          <a:bodyPr rtlCol="0" anchor="ctr"/>
+          <a:lstStyle/>
+          <a:p>
+            <a:pPr algn="ctr"/>
+          </a:p>
+        </p:txBody>
+      </p:sp>
+      <p:sp>
+        <p:nvSpPr>
+          <p:cNvPr id="4" name="Oval 3"/>
+          <p:cNvSpPr/>
+          <p:nvPr/>
+        </p:nvSpPr>
+        <p:spPr>
+          <a:xfrm>
+            <a:off x="-1097280" y="-914400"/>
+            <a:ext cx="3657600" cy="3657600"/>
+          </a:xfrm>
+          <a:prstGeom prst="ellipse">
+            <a:avLst/>
+          </a:prstGeom>
+          <a:solidFill>
+            <a:srgbClr val="336DD9"/>
+          </a:solidFill>
+          <a:ln>
+            <a:noFill/>
+          </a:ln>
+        </p:spPr>
+        <p:style>
+          <a:lnRef idx="1">
+            <a:schemeClr val="accent1"/>
+          </a:lnRef>
+          <a:fillRef idx="3">
+            <a:schemeClr val="accent1"/>
+          </a:fillRef>
+          <a:effectRef idx="2">
+            <a:schemeClr val="accent1"/>
+          </a:effectRef>
+          <a:fontRef idx="minor">
+            <a:schemeClr val="lt1"/>
+          </a:fontRef>
+        </p:style>
+        <p:txBody>
+          <a:bodyPr rtlCol="0" anchor="ctr"/>
+          <a:lstStyle/>
+          <a:p>
+            <a:pPr algn="ctr"/>
+          </a:p>
+        </p:txBody>
+      </p:sp>
+      <p:sp>
+        <p:nvSpPr>
           <p:cNvPr id="2" name="Title 1"/>
           <p:cNvSpPr>
             <a:spLocks noGrp="1"/>
@@ -4340,9 +4946,20 @@
           <a:lstStyle/>
           <a:p>
             <a:pPr>
-              <a:defRPr sz="3400"/>
+              <a:defRPr sz="3400" b="1">
+                <a:solidFill>
+                  <a:srgbClr val="ECF1FF"/>
+                </a:solidFill>
+                <a:latin typeface="Calibri"/>
+              </a:defRPr>
             </a:pPr>
             <a:r>
+              <a:rPr sz="3400" b="1">
+                <a:solidFill>
+                  <a:srgbClr val="ECF1FF"/>
+                </a:solidFill>
+                <a:latin typeface="Calibri"/>
+              </a:rPr>
               <a:t>Motivation and Context</a:t>
             </a:r>
           </a:p>
@@ -4364,27 +4981,103 @@
           <a:lstStyle/>
           <a:p>
             <a:pPr>
-              <a:defRPr sz="2000"/>
+              <a:defRPr sz="2000" b="0">
+                <a:solidFill>
+                  <a:srgbClr val="ECF1FF"/>
+                </a:solidFill>
+                <a:latin typeface="Calibri"/>
+              </a:defRPr>
             </a:pPr>
             <a:r>
+              <a:rPr sz="2000" b="0">
+                <a:solidFill>
+                  <a:srgbClr val="ECF1FF"/>
+                </a:solidFill>
+                <a:latin typeface="Calibri"/>
+              </a:rPr>
               <a:t>CTG is widely used in labour monitoring, but interpretation can be subjective.</a:t>
             </a:r>
           </a:p>
           <a:p>
             <a:pPr>
-              <a:defRPr sz="2000"/>
+              <a:defRPr sz="2000" b="0">
+                <a:solidFill>
+                  <a:srgbClr val="ECF1FF"/>
+                </a:solidFill>
+                <a:latin typeface="Calibri"/>
+              </a:defRPr>
             </a:pPr>
             <a:r>
+              <a:rPr sz="2000" b="0">
+                <a:solidFill>
+                  <a:srgbClr val="ECF1FF"/>
+                </a:solidFill>
+                <a:latin typeface="Calibri"/>
+              </a:rPr>
               <a:t>Clinical variability motivates transparent decision-support benchmarking.</a:t>
             </a:r>
           </a:p>
           <a:p>
             <a:pPr>
-              <a:defRPr sz="2000"/>
+              <a:defRPr sz="2000" b="0">
+                <a:solidFill>
+                  <a:srgbClr val="ECF1FF"/>
+                </a:solidFill>
+                <a:latin typeface="Calibri"/>
+              </a:defRPr>
             </a:pPr>
             <a:r>
+              <a:rPr sz="2000" b="0">
+                <a:solidFill>
+                  <a:srgbClr val="ECF1FF"/>
+                </a:solidFill>
+                <a:latin typeface="Calibri"/>
+              </a:rPr>
               <a:t>This benchmarking focus was shaped during Residency 4 at INFANT Research Centre.</a:t>
             </a:r>
+          </a:p>
+        </p:txBody>
+      </p:sp>
+      <p:sp>
+        <p:nvSpPr>
+          <p:cNvPr id="7" name="Rectangle 6"/>
+          <p:cNvSpPr/>
+          <p:nvPr/>
+        </p:nvSpPr>
+        <p:spPr>
+          <a:xfrm>
+            <a:off x="822960" y="1234440"/>
+            <a:ext cx="2011680" cy="45720"/>
+          </a:xfrm>
+          <a:prstGeom prst="rect">
+            <a:avLst/>
+          </a:prstGeom>
+          <a:solidFill>
+            <a:srgbClr val="3EB7DB"/>
+          </a:solidFill>
+          <a:ln>
+            <a:noFill/>
+          </a:ln>
+        </p:spPr>
+        <p:style>
+          <a:lnRef idx="1">
+            <a:schemeClr val="accent1"/>
+          </a:lnRef>
+          <a:fillRef idx="3">
+            <a:schemeClr val="accent1"/>
+          </a:fillRef>
+          <a:effectRef idx="2">
+            <a:schemeClr val="accent1"/>
+          </a:effectRef>
+          <a:fontRef idx="minor">
+            <a:schemeClr val="lt1"/>
+          </a:fontRef>
+        </p:style>
+        <p:txBody>
+          <a:bodyPr rtlCol="0" anchor="ctr"/>
+          <a:lstStyle/>
+          <a:p>
+            <a:pPr algn="ctr"/>
           </a:p>
         </p:txBody>
       </p:sp>
@@ -4399,6 +5092,14 @@
 <file path=ppt/slides/slide3.xml><?xml version="1.0" encoding="utf-8"?>
 <p:sld xmlns:a="http://schemas.openxmlformats.org/drawingml/2006/main" xmlns:p="http://schemas.openxmlformats.org/presentationml/2006/main" xmlns:r="http://schemas.openxmlformats.org/officeDocument/2006/relationships">
   <p:cSld>
+    <p:bg>
+      <p:bgPr>
+        <a:solidFill>
+          <a:srgbClr val="0B1020"/>
+        </a:solidFill>
+        <a:effectLst/>
+      </p:bgPr>
+    </p:bg>
     <p:spTree>
       <p:nvGrpSpPr>
         <p:cNvPr id="1" name=""/>
@@ -4408,6 +5109,135 @@
       <p:grpSpPr/>
       <p:sp>
         <p:nvSpPr>
+          <p:cNvPr id="6" name="Rectangle 5"/>
+          <p:cNvSpPr/>
+          <p:nvPr/>
+        </p:nvSpPr>
+        <p:spPr>
+          <a:xfrm>
+            <a:off x="0" y="0"/>
+            <a:ext cx="12188952" cy="109728"/>
+          </a:xfrm>
+          <a:prstGeom prst="rect">
+            <a:avLst/>
+          </a:prstGeom>
+          <a:solidFill>
+            <a:srgbClr val="3EB7DB"/>
+          </a:solidFill>
+          <a:ln>
+            <a:noFill/>
+          </a:ln>
+        </p:spPr>
+        <p:style>
+          <a:lnRef idx="1">
+            <a:schemeClr val="accent1"/>
+          </a:lnRef>
+          <a:fillRef idx="3">
+            <a:schemeClr val="accent1"/>
+          </a:fillRef>
+          <a:effectRef idx="2">
+            <a:schemeClr val="accent1"/>
+          </a:effectRef>
+          <a:fontRef idx="minor">
+            <a:schemeClr val="lt1"/>
+          </a:fontRef>
+        </p:style>
+        <p:txBody>
+          <a:bodyPr rtlCol="0" anchor="ctr"/>
+          <a:lstStyle/>
+          <a:p>
+            <a:pPr algn="ctr"/>
+          </a:p>
+        </p:txBody>
+      </p:sp>
+      <p:sp>
+        <p:nvSpPr>
+          <p:cNvPr id="5" name="Oval 4"/>
+          <p:cNvSpPr/>
+          <p:nvPr/>
+        </p:nvSpPr>
+        <p:spPr>
+          <a:xfrm>
+            <a:off x="7772400" y="4389120"/>
+            <a:ext cx="3657600" cy="3657600"/>
+          </a:xfrm>
+          <a:prstGeom prst="ellipse">
+            <a:avLst/>
+          </a:prstGeom>
+          <a:solidFill>
+            <a:srgbClr val="3EB7DB"/>
+          </a:solidFill>
+          <a:ln>
+            <a:noFill/>
+          </a:ln>
+        </p:spPr>
+        <p:style>
+          <a:lnRef idx="1">
+            <a:schemeClr val="accent1"/>
+          </a:lnRef>
+          <a:fillRef idx="3">
+            <a:schemeClr val="accent1"/>
+          </a:fillRef>
+          <a:effectRef idx="2">
+            <a:schemeClr val="accent1"/>
+          </a:effectRef>
+          <a:fontRef idx="minor">
+            <a:schemeClr val="lt1"/>
+          </a:fontRef>
+        </p:style>
+        <p:txBody>
+          <a:bodyPr rtlCol="0" anchor="ctr"/>
+          <a:lstStyle/>
+          <a:p>
+            <a:pPr algn="ctr"/>
+          </a:p>
+        </p:txBody>
+      </p:sp>
+      <p:sp>
+        <p:nvSpPr>
+          <p:cNvPr id="4" name="Oval 3"/>
+          <p:cNvSpPr/>
+          <p:nvPr/>
+        </p:nvSpPr>
+        <p:spPr>
+          <a:xfrm>
+            <a:off x="-1097280" y="-914400"/>
+            <a:ext cx="3657600" cy="3657600"/>
+          </a:xfrm>
+          <a:prstGeom prst="ellipse">
+            <a:avLst/>
+          </a:prstGeom>
+          <a:solidFill>
+            <a:srgbClr val="336DD9"/>
+          </a:solidFill>
+          <a:ln>
+            <a:noFill/>
+          </a:ln>
+        </p:spPr>
+        <p:style>
+          <a:lnRef idx="1">
+            <a:schemeClr val="accent1"/>
+          </a:lnRef>
+          <a:fillRef idx="3">
+            <a:schemeClr val="accent1"/>
+          </a:fillRef>
+          <a:effectRef idx="2">
+            <a:schemeClr val="accent1"/>
+          </a:effectRef>
+          <a:fontRef idx="minor">
+            <a:schemeClr val="lt1"/>
+          </a:fontRef>
+        </p:style>
+        <p:txBody>
+          <a:bodyPr rtlCol="0" anchor="ctr"/>
+          <a:lstStyle/>
+          <a:p>
+            <a:pPr algn="ctr"/>
+          </a:p>
+        </p:txBody>
+      </p:sp>
+      <p:sp>
+        <p:nvSpPr>
           <p:cNvPr id="2" name="Title 1"/>
           <p:cNvSpPr>
             <a:spLocks noGrp="1"/>
@@ -4422,9 +5252,20 @@
           <a:lstStyle/>
           <a:p>
             <a:pPr>
-              <a:defRPr sz="3400"/>
+              <a:defRPr sz="3400" b="1">
+                <a:solidFill>
+                  <a:srgbClr val="ECF1FF"/>
+                </a:solidFill>
+                <a:latin typeface="Calibri"/>
+              </a:defRPr>
             </a:pPr>
             <a:r>
+              <a:rPr sz="3400" b="1">
+                <a:solidFill>
+                  <a:srgbClr val="ECF1FF"/>
+                </a:solidFill>
+                <a:latin typeface="Calibri"/>
+              </a:rPr>
               <a:t>Aim and Scope</a:t>
             </a:r>
           </a:p>
@@ -4446,35 +5287,122 @@
           <a:lstStyle/>
           <a:p>
             <a:pPr>
-              <a:defRPr sz="2000"/>
+              <a:defRPr sz="2000" b="0">
+                <a:solidFill>
+                  <a:srgbClr val="ECF1FF"/>
+                </a:solidFill>
+                <a:latin typeface="Calibri"/>
+              </a:defRPr>
             </a:pPr>
             <a:r>
+              <a:rPr sz="2000" b="0">
+                <a:solidFill>
+                  <a:srgbClr val="ECF1FF"/>
+                </a:solidFill>
+                <a:latin typeface="Calibri"/>
+              </a:rPr>
               <a:t>Aim: benchmark supervised classifiers for fetal heart rate pattern detection.</a:t>
             </a:r>
           </a:p>
           <a:p>
             <a:pPr>
-              <a:defRPr sz="2000"/>
+              <a:defRPr sz="2000" b="0">
+                <a:solidFill>
+                  <a:srgbClr val="ECF1FF"/>
+                </a:solidFill>
+                <a:latin typeface="Calibri"/>
+              </a:defRPr>
             </a:pPr>
             <a:r>
+              <a:rPr sz="2000" b="0">
+                <a:solidFill>
+                  <a:srgbClr val="ECF1FF"/>
+                </a:solidFill>
+                <a:latin typeface="Calibri"/>
+              </a:rPr>
               <a:t>Models compared: Random Forest (feature-based) vs 1D-CNN (raw-signal).</a:t>
             </a:r>
           </a:p>
           <a:p>
             <a:pPr>
-              <a:defRPr sz="2000"/>
+              <a:defRPr sz="2000" b="0">
+                <a:solidFill>
+                  <a:srgbClr val="ECF1FF"/>
+                </a:solidFill>
+                <a:latin typeface="Calibri"/>
+              </a:defRPr>
             </a:pPr>
             <a:r>
+              <a:rPr sz="2000" b="0">
+                <a:solidFill>
+                  <a:srgbClr val="ECF1FF"/>
+                </a:solidFill>
+                <a:latin typeface="Calibri"/>
+              </a:rPr>
               <a:t>Scope: within-cohort CTU-UHB benchmark with weakly supervised labels.</a:t>
             </a:r>
           </a:p>
           <a:p>
             <a:pPr>
-              <a:defRPr sz="2000"/>
+              <a:defRPr sz="2000" b="0">
+                <a:solidFill>
+                  <a:srgbClr val="ECF1FF"/>
+                </a:solidFill>
+                <a:latin typeface="Calibri"/>
+              </a:defRPr>
             </a:pPr>
             <a:r>
+              <a:rPr sz="2000" b="0">
+                <a:solidFill>
+                  <a:srgbClr val="ECF1FF"/>
+                </a:solidFill>
+                <a:latin typeface="Calibri"/>
+              </a:rPr>
               <a:t>Claim boundary: fixed-split comparative evidence, not inferential repeated-run ranking.</a:t>
             </a:r>
+          </a:p>
+        </p:txBody>
+      </p:sp>
+      <p:sp>
+        <p:nvSpPr>
+          <p:cNvPr id="7" name="Rectangle 6"/>
+          <p:cNvSpPr/>
+          <p:nvPr/>
+        </p:nvSpPr>
+        <p:spPr>
+          <a:xfrm>
+            <a:off x="822960" y="1234440"/>
+            <a:ext cx="2011680" cy="45720"/>
+          </a:xfrm>
+          <a:prstGeom prst="rect">
+            <a:avLst/>
+          </a:prstGeom>
+          <a:solidFill>
+            <a:srgbClr val="3EB7DB"/>
+          </a:solidFill>
+          <a:ln>
+            <a:noFill/>
+          </a:ln>
+        </p:spPr>
+        <p:style>
+          <a:lnRef idx="1">
+            <a:schemeClr val="accent1"/>
+          </a:lnRef>
+          <a:fillRef idx="3">
+            <a:schemeClr val="accent1"/>
+          </a:fillRef>
+          <a:effectRef idx="2">
+            <a:schemeClr val="accent1"/>
+          </a:effectRef>
+          <a:fontRef idx="minor">
+            <a:schemeClr val="lt1"/>
+          </a:fontRef>
+        </p:style>
+        <p:txBody>
+          <a:bodyPr rtlCol="0" anchor="ctr"/>
+          <a:lstStyle/>
+          <a:p>
+            <a:pPr algn="ctr"/>
           </a:p>
         </p:txBody>
       </p:sp>
@@ -4489,6 +5417,14 @@
 <file path=ppt/slides/slide4.xml><?xml version="1.0" encoding="utf-8"?>
 <p:sld xmlns:a="http://schemas.openxmlformats.org/drawingml/2006/main" xmlns:p="http://schemas.openxmlformats.org/presentationml/2006/main" xmlns:r="http://schemas.openxmlformats.org/officeDocument/2006/relationships">
   <p:cSld>
+    <p:bg>
+      <p:bgPr>
+        <a:solidFill>
+          <a:srgbClr val="0B1020"/>
+        </a:solidFill>
+        <a:effectLst/>
+      </p:bgPr>
+    </p:bg>
     <p:spTree>
       <p:nvGrpSpPr>
         <p:cNvPr id="1" name=""/>
@@ -4498,6 +5434,135 @@
       <p:grpSpPr/>
       <p:sp>
         <p:nvSpPr>
+          <p:cNvPr id="6" name="Rectangle 5"/>
+          <p:cNvSpPr/>
+          <p:nvPr/>
+        </p:nvSpPr>
+        <p:spPr>
+          <a:xfrm>
+            <a:off x="0" y="0"/>
+            <a:ext cx="12188952" cy="109728"/>
+          </a:xfrm>
+          <a:prstGeom prst="rect">
+            <a:avLst/>
+          </a:prstGeom>
+          <a:solidFill>
+            <a:srgbClr val="3EB7DB"/>
+          </a:solidFill>
+          <a:ln>
+            <a:noFill/>
+          </a:ln>
+        </p:spPr>
+        <p:style>
+          <a:lnRef idx="1">
+            <a:schemeClr val="accent1"/>
+          </a:lnRef>
+          <a:fillRef idx="3">
+            <a:schemeClr val="accent1"/>
+          </a:fillRef>
+          <a:effectRef idx="2">
+            <a:schemeClr val="accent1"/>
+          </a:effectRef>
+          <a:fontRef idx="minor">
+            <a:schemeClr val="lt1"/>
+          </a:fontRef>
+        </p:style>
+        <p:txBody>
+          <a:bodyPr rtlCol="0" anchor="ctr"/>
+          <a:lstStyle/>
+          <a:p>
+            <a:pPr algn="ctr"/>
+          </a:p>
+        </p:txBody>
+      </p:sp>
+      <p:sp>
+        <p:nvSpPr>
+          <p:cNvPr id="5" name="Oval 4"/>
+          <p:cNvSpPr/>
+          <p:nvPr/>
+        </p:nvSpPr>
+        <p:spPr>
+          <a:xfrm>
+            <a:off x="7772400" y="4389120"/>
+            <a:ext cx="3657600" cy="3657600"/>
+          </a:xfrm>
+          <a:prstGeom prst="ellipse">
+            <a:avLst/>
+          </a:prstGeom>
+          <a:solidFill>
+            <a:srgbClr val="3EB7DB"/>
+          </a:solidFill>
+          <a:ln>
+            <a:noFill/>
+          </a:ln>
+        </p:spPr>
+        <p:style>
+          <a:lnRef idx="1">
+            <a:schemeClr val="accent1"/>
+          </a:lnRef>
+          <a:fillRef idx="3">
+            <a:schemeClr val="accent1"/>
+          </a:fillRef>
+          <a:effectRef idx="2">
+            <a:schemeClr val="accent1"/>
+          </a:effectRef>
+          <a:fontRef idx="minor">
+            <a:schemeClr val="lt1"/>
+          </a:fontRef>
+        </p:style>
+        <p:txBody>
+          <a:bodyPr rtlCol="0" anchor="ctr"/>
+          <a:lstStyle/>
+          <a:p>
+            <a:pPr algn="ctr"/>
+          </a:p>
+        </p:txBody>
+      </p:sp>
+      <p:sp>
+        <p:nvSpPr>
+          <p:cNvPr id="4" name="Oval 3"/>
+          <p:cNvSpPr/>
+          <p:nvPr/>
+        </p:nvSpPr>
+        <p:spPr>
+          <a:xfrm>
+            <a:off x="-1097280" y="-914400"/>
+            <a:ext cx="3657600" cy="3657600"/>
+          </a:xfrm>
+          <a:prstGeom prst="ellipse">
+            <a:avLst/>
+          </a:prstGeom>
+          <a:solidFill>
+            <a:srgbClr val="336DD9"/>
+          </a:solidFill>
+          <a:ln>
+            <a:noFill/>
+          </a:ln>
+        </p:spPr>
+        <p:style>
+          <a:lnRef idx="1">
+            <a:schemeClr val="accent1"/>
+          </a:lnRef>
+          <a:fillRef idx="3">
+            <a:schemeClr val="accent1"/>
+          </a:fillRef>
+          <a:effectRef idx="2">
+            <a:schemeClr val="accent1"/>
+          </a:effectRef>
+          <a:fontRef idx="minor">
+            <a:schemeClr val="lt1"/>
+          </a:fontRef>
+        </p:style>
+        <p:txBody>
+          <a:bodyPr rtlCol="0" anchor="ctr"/>
+          <a:lstStyle/>
+          <a:p>
+            <a:pPr algn="ctr"/>
+          </a:p>
+        </p:txBody>
+      </p:sp>
+      <p:sp>
+        <p:nvSpPr>
           <p:cNvPr id="2" name="Title 1"/>
           <p:cNvSpPr>
             <a:spLocks noGrp="1"/>
@@ -4512,9 +5577,20 @@
           <a:lstStyle/>
           <a:p>
             <a:pPr>
-              <a:defRPr sz="3400"/>
+              <a:defRPr sz="3400" b="1">
+                <a:solidFill>
+                  <a:srgbClr val="ECF1FF"/>
+                </a:solidFill>
+                <a:latin typeface="Calibri"/>
+              </a:defRPr>
             </a:pPr>
             <a:r>
+              <a:rPr sz="3400" b="1">
+                <a:solidFill>
+                  <a:srgbClr val="ECF1FF"/>
+                </a:solidFill>
+                <a:latin typeface="Calibri"/>
+              </a:rPr>
               <a:t>Benchmark Design and Fairness Controls</a:t>
             </a:r>
           </a:p>
@@ -4536,35 +5612,122 @@
           <a:lstStyle/>
           <a:p>
             <a:pPr>
-              <a:defRPr sz="2000"/>
+              <a:defRPr sz="2000" b="0">
+                <a:solidFill>
+                  <a:srgbClr val="ECF1FF"/>
+                </a:solidFill>
+                <a:latin typeface="Calibri"/>
+              </a:defRPr>
             </a:pPr>
             <a:r>
+              <a:rPr sz="2000" b="0">
+                <a:solidFill>
+                  <a:srgbClr val="ECF1FF"/>
+                </a:solidFill>
+                <a:latin typeface="Calibri"/>
+              </a:rPr>
               <a:t>Shared preprocessing and leakage-aware grouped splitting by record ID.</a:t>
             </a:r>
           </a:p>
           <a:p>
             <a:pPr>
-              <a:defRPr sz="2000"/>
+              <a:defRPr sz="2000" b="0">
+                <a:solidFill>
+                  <a:srgbClr val="ECF1FF"/>
+                </a:solidFill>
+                <a:latin typeface="Calibri"/>
+              </a:defRPr>
             </a:pPr>
             <a:r>
+              <a:rPr sz="2000" b="0">
+                <a:solidFill>
+                  <a:srgbClr val="ECF1FF"/>
+                </a:solidFill>
+                <a:latin typeface="Calibri"/>
+              </a:rPr>
               <a:t>Common evaluation criteria: class-wise and aggregate metrics.</a:t>
             </a:r>
           </a:p>
           <a:p>
             <a:pPr>
-              <a:defRPr sz="2000"/>
+              <a:defRPr sz="2000" b="0">
+                <a:solidFill>
+                  <a:srgbClr val="ECF1FF"/>
+                </a:solidFill>
+                <a:latin typeface="Calibri"/>
+              </a:defRPr>
             </a:pPr>
             <a:r>
+              <a:rPr sz="2000" b="0">
+                <a:solidFill>
+                  <a:srgbClr val="ECF1FF"/>
+                </a:solidFill>
+                <a:latin typeface="Calibri"/>
+              </a:rPr>
               <a:t>Additional evidence: efficiency, confusion analysis, threshold behaviour, interpretability.</a:t>
             </a:r>
           </a:p>
           <a:p>
             <a:pPr>
-              <a:defRPr sz="2000"/>
+              <a:defRPr sz="2000" b="0">
+                <a:solidFill>
+                  <a:srgbClr val="ECF1FF"/>
+                </a:solidFill>
+                <a:latin typeface="Calibri"/>
+              </a:defRPr>
             </a:pPr>
             <a:r>
+              <a:rPr sz="2000" b="0">
+                <a:solidFill>
+                  <a:srgbClr val="ECF1FF"/>
+                </a:solidFill>
+                <a:latin typeface="Calibri"/>
+              </a:rPr>
               <a:t>Reproducibility controls: fixed seed policy, split manifests, JSON/CSV artifacts.</a:t>
             </a:r>
+          </a:p>
+        </p:txBody>
+      </p:sp>
+      <p:sp>
+        <p:nvSpPr>
+          <p:cNvPr id="7" name="Rectangle 6"/>
+          <p:cNvSpPr/>
+          <p:nvPr/>
+        </p:nvSpPr>
+        <p:spPr>
+          <a:xfrm>
+            <a:off x="822960" y="1234440"/>
+            <a:ext cx="2011680" cy="45720"/>
+          </a:xfrm>
+          <a:prstGeom prst="rect">
+            <a:avLst/>
+          </a:prstGeom>
+          <a:solidFill>
+            <a:srgbClr val="3EB7DB"/>
+          </a:solidFill>
+          <a:ln>
+            <a:noFill/>
+          </a:ln>
+        </p:spPr>
+        <p:style>
+          <a:lnRef idx="1">
+            <a:schemeClr val="accent1"/>
+          </a:lnRef>
+          <a:fillRef idx="3">
+            <a:schemeClr val="accent1"/>
+          </a:fillRef>
+          <a:effectRef idx="2">
+            <a:schemeClr val="accent1"/>
+          </a:effectRef>
+          <a:fontRef idx="minor">
+            <a:schemeClr val="lt1"/>
+          </a:fontRef>
+        </p:style>
+        <p:txBody>
+          <a:bodyPr rtlCol="0" anchor="ctr"/>
+          <a:lstStyle/>
+          <a:p>
+            <a:pPr algn="ctr"/>
           </a:p>
         </p:txBody>
       </p:sp>
@@ -4579,6 +5742,14 @@
 <file path=ppt/slides/slide5.xml><?xml version="1.0" encoding="utf-8"?>
 <p:sld xmlns:a="http://schemas.openxmlformats.org/drawingml/2006/main" xmlns:p="http://schemas.openxmlformats.org/presentationml/2006/main" xmlns:r="http://schemas.openxmlformats.org/officeDocument/2006/relationships">
   <p:cSld>
+    <p:bg>
+      <p:bgPr>
+        <a:solidFill>
+          <a:srgbClr val="0B1020"/>
+        </a:solidFill>
+        <a:effectLst/>
+      </p:bgPr>
+    </p:bg>
     <p:spTree>
       <p:nvGrpSpPr>
         <p:cNvPr id="1" name=""/>
@@ -4588,6 +5759,135 @@
       <p:grpSpPr/>
       <p:sp>
         <p:nvSpPr>
+          <p:cNvPr id="6" name="Rectangle 5"/>
+          <p:cNvSpPr/>
+          <p:nvPr/>
+        </p:nvSpPr>
+        <p:spPr>
+          <a:xfrm>
+            <a:off x="0" y="0"/>
+            <a:ext cx="12188952" cy="109728"/>
+          </a:xfrm>
+          <a:prstGeom prst="rect">
+            <a:avLst/>
+          </a:prstGeom>
+          <a:solidFill>
+            <a:srgbClr val="3EB7DB"/>
+          </a:solidFill>
+          <a:ln>
+            <a:noFill/>
+          </a:ln>
+        </p:spPr>
+        <p:style>
+          <a:lnRef idx="1">
+            <a:schemeClr val="accent1"/>
+          </a:lnRef>
+          <a:fillRef idx="3">
+            <a:schemeClr val="accent1"/>
+          </a:fillRef>
+          <a:effectRef idx="2">
+            <a:schemeClr val="accent1"/>
+          </a:effectRef>
+          <a:fontRef idx="minor">
+            <a:schemeClr val="lt1"/>
+          </a:fontRef>
+        </p:style>
+        <p:txBody>
+          <a:bodyPr rtlCol="0" anchor="ctr"/>
+          <a:lstStyle/>
+          <a:p>
+            <a:pPr algn="ctr"/>
+          </a:p>
+        </p:txBody>
+      </p:sp>
+      <p:sp>
+        <p:nvSpPr>
+          <p:cNvPr id="5" name="Oval 4"/>
+          <p:cNvSpPr/>
+          <p:nvPr/>
+        </p:nvSpPr>
+        <p:spPr>
+          <a:xfrm>
+            <a:off x="7772400" y="4389120"/>
+            <a:ext cx="3657600" cy="3657600"/>
+          </a:xfrm>
+          <a:prstGeom prst="ellipse">
+            <a:avLst/>
+          </a:prstGeom>
+          <a:solidFill>
+            <a:srgbClr val="3EB7DB"/>
+          </a:solidFill>
+          <a:ln>
+            <a:noFill/>
+          </a:ln>
+        </p:spPr>
+        <p:style>
+          <a:lnRef idx="1">
+            <a:schemeClr val="accent1"/>
+          </a:lnRef>
+          <a:fillRef idx="3">
+            <a:schemeClr val="accent1"/>
+          </a:fillRef>
+          <a:effectRef idx="2">
+            <a:schemeClr val="accent1"/>
+          </a:effectRef>
+          <a:fontRef idx="minor">
+            <a:schemeClr val="lt1"/>
+          </a:fontRef>
+        </p:style>
+        <p:txBody>
+          <a:bodyPr rtlCol="0" anchor="ctr"/>
+          <a:lstStyle/>
+          <a:p>
+            <a:pPr algn="ctr"/>
+          </a:p>
+        </p:txBody>
+      </p:sp>
+      <p:sp>
+        <p:nvSpPr>
+          <p:cNvPr id="4" name="Oval 3"/>
+          <p:cNvSpPr/>
+          <p:nvPr/>
+        </p:nvSpPr>
+        <p:spPr>
+          <a:xfrm>
+            <a:off x="-1097280" y="-914400"/>
+            <a:ext cx="3657600" cy="3657600"/>
+          </a:xfrm>
+          <a:prstGeom prst="ellipse">
+            <a:avLst/>
+          </a:prstGeom>
+          <a:solidFill>
+            <a:srgbClr val="336DD9"/>
+          </a:solidFill>
+          <a:ln>
+            <a:noFill/>
+          </a:ln>
+        </p:spPr>
+        <p:style>
+          <a:lnRef idx="1">
+            <a:schemeClr val="accent1"/>
+          </a:lnRef>
+          <a:fillRef idx="3">
+            <a:schemeClr val="accent1"/>
+          </a:fillRef>
+          <a:effectRef idx="2">
+            <a:schemeClr val="accent1"/>
+          </a:effectRef>
+          <a:fontRef idx="minor">
+            <a:schemeClr val="lt1"/>
+          </a:fontRef>
+        </p:style>
+        <p:txBody>
+          <a:bodyPr rtlCol="0" anchor="ctr"/>
+          <a:lstStyle/>
+          <a:p>
+            <a:pPr algn="ctr"/>
+          </a:p>
+        </p:txBody>
+      </p:sp>
+      <p:sp>
+        <p:nvSpPr>
           <p:cNvPr id="2" name="Title 1"/>
           <p:cNvSpPr>
             <a:spLocks noGrp="1"/>
@@ -4602,9 +5902,20 @@
           <a:lstStyle/>
           <a:p>
             <a:pPr>
-              <a:defRPr sz="3400"/>
+              <a:defRPr sz="3400" b="1">
+                <a:solidFill>
+                  <a:srgbClr val="ECF1FF"/>
+                </a:solidFill>
+                <a:latin typeface="Calibri"/>
+              </a:defRPr>
             </a:pPr>
             <a:r>
+              <a:rPr sz="3400" b="1">
+                <a:solidFill>
+                  <a:srgbClr val="ECF1FF"/>
+                </a:solidFill>
+                <a:latin typeface="Calibri"/>
+              </a:rPr>
               <a:t>Pipeline</a:t>
             </a:r>
           </a:p>
@@ -4626,35 +5937,122 @@
           <a:lstStyle/>
           <a:p>
             <a:pPr>
-              <a:defRPr sz="2000"/>
+              <a:defRPr sz="2000" b="0">
+                <a:solidFill>
+                  <a:srgbClr val="ECF1FF"/>
+                </a:solidFill>
+                <a:latin typeface="Calibri"/>
+              </a:defRPr>
             </a:pPr>
             <a:r>
+              <a:rPr sz="2000" b="0">
+                <a:solidFill>
+                  <a:srgbClr val="ECF1FF"/>
+                </a:solidFill>
+                <a:latin typeface="Calibri"/>
+              </a:rPr>
               <a:t>Signal quality control and preprocessing</a:t>
             </a:r>
           </a:p>
           <a:p>
             <a:pPr>
-              <a:defRPr sz="2000"/>
+              <a:defRPr sz="2000" b="0">
+                <a:solidFill>
+                  <a:srgbClr val="ECF1FF"/>
+                </a:solidFill>
+                <a:latin typeface="Calibri"/>
+              </a:defRPr>
             </a:pPr>
             <a:r>
+              <a:rPr sz="2000" b="0">
+                <a:solidFill>
+                  <a:srgbClr val="ECF1FF"/>
+                </a:solidFill>
+                <a:latin typeface="Calibri"/>
+              </a:rPr>
               <a:t>Windowing and feature extraction</a:t>
             </a:r>
           </a:p>
           <a:p>
             <a:pPr>
-              <a:defRPr sz="2000"/>
+              <a:defRPr sz="2000" b="0">
+                <a:solidFill>
+                  <a:srgbClr val="ECF1FF"/>
+                </a:solidFill>
+                <a:latin typeface="Calibri"/>
+              </a:defRPr>
             </a:pPr>
             <a:r>
+              <a:rPr sz="2000" b="0">
+                <a:solidFill>
+                  <a:srgbClr val="ECF1FF"/>
+                </a:solidFill>
+                <a:latin typeface="Calibri"/>
+              </a:rPr>
               <a:t>Model training with grouped holdout protocol</a:t>
             </a:r>
           </a:p>
           <a:p>
             <a:pPr>
-              <a:defRPr sz="2000"/>
+              <a:defRPr sz="2000" b="0">
+                <a:solidFill>
+                  <a:srgbClr val="ECF1FF"/>
+                </a:solidFill>
+                <a:latin typeface="Calibri"/>
+              </a:defRPr>
             </a:pPr>
             <a:r>
+              <a:rPr sz="2000" b="0">
+                <a:solidFill>
+                  <a:srgbClr val="ECF1FF"/>
+                </a:solidFill>
+                <a:latin typeface="Calibri"/>
+              </a:rPr>
               <a:t>Evaluation, error analysis, thresholding, and post-processing review</a:t>
             </a:r>
+          </a:p>
+        </p:txBody>
+      </p:sp>
+      <p:sp>
+        <p:nvSpPr>
+          <p:cNvPr id="7" name="Rectangle 6"/>
+          <p:cNvSpPr/>
+          <p:nvPr/>
+        </p:nvSpPr>
+        <p:spPr>
+          <a:xfrm>
+            <a:off x="822960" y="1234440"/>
+            <a:ext cx="2011680" cy="45720"/>
+          </a:xfrm>
+          <a:prstGeom prst="rect">
+            <a:avLst/>
+          </a:prstGeom>
+          <a:solidFill>
+            <a:srgbClr val="3EB7DB"/>
+          </a:solidFill>
+          <a:ln>
+            <a:noFill/>
+          </a:ln>
+        </p:spPr>
+        <p:style>
+          <a:lnRef idx="1">
+            <a:schemeClr val="accent1"/>
+          </a:lnRef>
+          <a:fillRef idx="3">
+            <a:schemeClr val="accent1"/>
+          </a:fillRef>
+          <a:effectRef idx="2">
+            <a:schemeClr val="accent1"/>
+          </a:effectRef>
+          <a:fontRef idx="minor">
+            <a:schemeClr val="lt1"/>
+          </a:fontRef>
+        </p:style>
+        <p:txBody>
+          <a:bodyPr rtlCol="0" anchor="ctr"/>
+          <a:lstStyle/>
+          <a:p>
+            <a:pPr algn="ctr"/>
           </a:p>
         </p:txBody>
       </p:sp>
@@ -4669,6 +6067,14 @@
 <file path=ppt/slides/slide6.xml><?xml version="1.0" encoding="utf-8"?>
 <p:sld xmlns:a="http://schemas.openxmlformats.org/drawingml/2006/main" xmlns:p="http://schemas.openxmlformats.org/presentationml/2006/main" xmlns:r="http://schemas.openxmlformats.org/officeDocument/2006/relationships">
   <p:cSld>
+    <p:bg>
+      <p:bgPr>
+        <a:solidFill>
+          <a:srgbClr val="0B1020"/>
+        </a:solidFill>
+        <a:effectLst/>
+      </p:bgPr>
+    </p:bg>
     <p:spTree>
       <p:nvGrpSpPr>
         <p:cNvPr id="1" name=""/>
@@ -4678,6 +6084,135 @@
       <p:grpSpPr/>
       <p:sp>
         <p:nvSpPr>
+          <p:cNvPr id="6" name="Rectangle 5"/>
+          <p:cNvSpPr/>
+          <p:nvPr/>
+        </p:nvSpPr>
+        <p:spPr>
+          <a:xfrm>
+            <a:off x="0" y="0"/>
+            <a:ext cx="12188952" cy="109728"/>
+          </a:xfrm>
+          <a:prstGeom prst="rect">
+            <a:avLst/>
+          </a:prstGeom>
+          <a:solidFill>
+            <a:srgbClr val="3EB7DB"/>
+          </a:solidFill>
+          <a:ln>
+            <a:noFill/>
+          </a:ln>
+        </p:spPr>
+        <p:style>
+          <a:lnRef idx="1">
+            <a:schemeClr val="accent1"/>
+          </a:lnRef>
+          <a:fillRef idx="3">
+            <a:schemeClr val="accent1"/>
+          </a:fillRef>
+          <a:effectRef idx="2">
+            <a:schemeClr val="accent1"/>
+          </a:effectRef>
+          <a:fontRef idx="minor">
+            <a:schemeClr val="lt1"/>
+          </a:fontRef>
+        </p:style>
+        <p:txBody>
+          <a:bodyPr rtlCol="0" anchor="ctr"/>
+          <a:lstStyle/>
+          <a:p>
+            <a:pPr algn="ctr"/>
+          </a:p>
+        </p:txBody>
+      </p:sp>
+      <p:sp>
+        <p:nvSpPr>
+          <p:cNvPr id="5" name="Oval 4"/>
+          <p:cNvSpPr/>
+          <p:nvPr/>
+        </p:nvSpPr>
+        <p:spPr>
+          <a:xfrm>
+            <a:off x="7772400" y="4389120"/>
+            <a:ext cx="3657600" cy="3657600"/>
+          </a:xfrm>
+          <a:prstGeom prst="ellipse">
+            <a:avLst/>
+          </a:prstGeom>
+          <a:solidFill>
+            <a:srgbClr val="3EB7DB"/>
+          </a:solidFill>
+          <a:ln>
+            <a:noFill/>
+          </a:ln>
+        </p:spPr>
+        <p:style>
+          <a:lnRef idx="1">
+            <a:schemeClr val="accent1"/>
+          </a:lnRef>
+          <a:fillRef idx="3">
+            <a:schemeClr val="accent1"/>
+          </a:fillRef>
+          <a:effectRef idx="2">
+            <a:schemeClr val="accent1"/>
+          </a:effectRef>
+          <a:fontRef idx="minor">
+            <a:schemeClr val="lt1"/>
+          </a:fontRef>
+        </p:style>
+        <p:txBody>
+          <a:bodyPr rtlCol="0" anchor="ctr"/>
+          <a:lstStyle/>
+          <a:p>
+            <a:pPr algn="ctr"/>
+          </a:p>
+        </p:txBody>
+      </p:sp>
+      <p:sp>
+        <p:nvSpPr>
+          <p:cNvPr id="4" name="Oval 3"/>
+          <p:cNvSpPr/>
+          <p:nvPr/>
+        </p:nvSpPr>
+        <p:spPr>
+          <a:xfrm>
+            <a:off x="-1097280" y="-914400"/>
+            <a:ext cx="3657600" cy="3657600"/>
+          </a:xfrm>
+          <a:prstGeom prst="ellipse">
+            <a:avLst/>
+          </a:prstGeom>
+          <a:solidFill>
+            <a:srgbClr val="336DD9"/>
+          </a:solidFill>
+          <a:ln>
+            <a:noFill/>
+          </a:ln>
+        </p:spPr>
+        <p:style>
+          <a:lnRef idx="1">
+            <a:schemeClr val="accent1"/>
+          </a:lnRef>
+          <a:fillRef idx="3">
+            <a:schemeClr val="accent1"/>
+          </a:fillRef>
+          <a:effectRef idx="2">
+            <a:schemeClr val="accent1"/>
+          </a:effectRef>
+          <a:fontRef idx="minor">
+            <a:schemeClr val="lt1"/>
+          </a:fontRef>
+        </p:style>
+        <p:txBody>
+          <a:bodyPr rtlCol="0" anchor="ctr"/>
+          <a:lstStyle/>
+          <a:p>
+            <a:pPr algn="ctr"/>
+          </a:p>
+        </p:txBody>
+      </p:sp>
+      <p:sp>
+        <p:nvSpPr>
           <p:cNvPr id="2" name="Title 1"/>
           <p:cNvSpPr>
             <a:spLocks noGrp="1"/>
@@ -4692,9 +6227,20 @@
           <a:lstStyle/>
           <a:p>
             <a:pPr>
-              <a:defRPr sz="3400"/>
+              <a:defRPr sz="3400" b="1">
+                <a:solidFill>
+                  <a:srgbClr val="ECF1FF"/>
+                </a:solidFill>
+                <a:latin typeface="Calibri"/>
+              </a:defRPr>
             </a:pPr>
             <a:r>
+              <a:rPr sz="3400" b="1">
+                <a:solidFill>
+                  <a:srgbClr val="ECF1FF"/>
+                </a:solidFill>
+                <a:latin typeface="Calibri"/>
+              </a:rPr>
               <a:t>Headline Results</a:t>
             </a:r>
           </a:p>
@@ -4716,35 +6262,122 @@
           <a:lstStyle/>
           <a:p>
             <a:pPr>
-              <a:defRPr sz="2000"/>
+              <a:defRPr sz="2000" b="0">
+                <a:solidFill>
+                  <a:srgbClr val="ECF1FF"/>
+                </a:solidFill>
+                <a:latin typeface="Calibri"/>
+              </a:defRPr>
             </a:pPr>
             <a:r>
+              <a:rPr sz="2000" b="0">
+                <a:solidFill>
+                  <a:srgbClr val="ECF1FF"/>
+                </a:solidFill>
+                <a:latin typeface="Calibri"/>
+              </a:rPr>
               <a:t>Held-out windows: RF 95.55% accuracy, macro-F1 0.945.</a:t>
             </a:r>
           </a:p>
           <a:p>
             <a:pPr>
-              <a:defRPr sz="2000"/>
+              <a:defRPr sz="2000" b="0">
+                <a:solidFill>
+                  <a:srgbClr val="ECF1FF"/>
+                </a:solidFill>
+                <a:latin typeface="Calibri"/>
+              </a:defRPr>
             </a:pPr>
             <a:r>
+              <a:rPr sz="2000" b="0">
+                <a:solidFill>
+                  <a:srgbClr val="ECF1FF"/>
+                </a:solidFill>
+                <a:latin typeface="Calibri"/>
+              </a:rPr>
               <a:t>Held-out windows: CNN 65.31% accuracy, macro-F1 0.584.</a:t>
             </a:r>
           </a:p>
           <a:p>
             <a:pPr>
-              <a:defRPr sz="2000"/>
+              <a:defRPr sz="2000" b="0">
+                <a:solidFill>
+                  <a:srgbClr val="ECF1FF"/>
+                </a:solidFill>
+                <a:latin typeface="Calibri"/>
+              </a:defRPr>
             </a:pPr>
             <a:r>
+              <a:rPr sz="2000" b="0">
+                <a:solidFill>
+                  <a:srgbClr val="ECF1FF"/>
+                </a:solidFill>
+                <a:latin typeface="Calibri"/>
+              </a:rPr>
               <a:t>Record-level CNN drops to 48.19% accuracy, macro-F1 0.383.</a:t>
             </a:r>
           </a:p>
           <a:p>
             <a:pPr>
-              <a:defRPr sz="2000"/>
+              <a:defRPr sz="2000" b="0">
+                <a:solidFill>
+                  <a:srgbClr val="ECF1FF"/>
+                </a:solidFill>
+                <a:latin typeface="Calibri"/>
+              </a:defRPr>
             </a:pPr>
             <a:r>
+              <a:rPr sz="2000" b="0">
+                <a:solidFill>
+                  <a:srgbClr val="ECF1FF"/>
+                </a:solidFill>
+                <a:latin typeface="Calibri"/>
+              </a:rPr>
               <a:t>Result: RF is the stronger current baseline under this data regime.</a:t>
             </a:r>
+          </a:p>
+        </p:txBody>
+      </p:sp>
+      <p:sp>
+        <p:nvSpPr>
+          <p:cNvPr id="7" name="Rectangle 6"/>
+          <p:cNvSpPr/>
+          <p:nvPr/>
+        </p:nvSpPr>
+        <p:spPr>
+          <a:xfrm>
+            <a:off x="822960" y="1234440"/>
+            <a:ext cx="2011680" cy="45720"/>
+          </a:xfrm>
+          <a:prstGeom prst="rect">
+            <a:avLst/>
+          </a:prstGeom>
+          <a:solidFill>
+            <a:srgbClr val="3EB7DB"/>
+          </a:solidFill>
+          <a:ln>
+            <a:noFill/>
+          </a:ln>
+        </p:spPr>
+        <p:style>
+          <a:lnRef idx="1">
+            <a:schemeClr val="accent1"/>
+          </a:lnRef>
+          <a:fillRef idx="3">
+            <a:schemeClr val="accent1"/>
+          </a:fillRef>
+          <a:effectRef idx="2">
+            <a:schemeClr val="accent1"/>
+          </a:effectRef>
+          <a:fontRef idx="minor">
+            <a:schemeClr val="lt1"/>
+          </a:fontRef>
+        </p:style>
+        <p:txBody>
+          <a:bodyPr rtlCol="0" anchor="ctr"/>
+          <a:lstStyle/>
+          <a:p>
+            <a:pPr algn="ctr"/>
           </a:p>
         </p:txBody>
       </p:sp>
@@ -4759,6 +6392,14 @@
 <file path=ppt/slides/slide7.xml><?xml version="1.0" encoding="utf-8"?>
 <p:sld xmlns:a="http://schemas.openxmlformats.org/drawingml/2006/main" xmlns:p="http://schemas.openxmlformats.org/presentationml/2006/main" xmlns:r="http://schemas.openxmlformats.org/officeDocument/2006/relationships">
   <p:cSld>
+    <p:bg>
+      <p:bgPr>
+        <a:solidFill>
+          <a:srgbClr val="0B1020"/>
+        </a:solidFill>
+        <a:effectLst/>
+      </p:bgPr>
+    </p:bg>
     <p:spTree>
       <p:nvGrpSpPr>
         <p:cNvPr id="1" name=""/>
@@ -4768,6 +6409,135 @@
       <p:grpSpPr/>
       <p:sp>
         <p:nvSpPr>
+          <p:cNvPr id="5" name="Rectangle 4"/>
+          <p:cNvSpPr/>
+          <p:nvPr/>
+        </p:nvSpPr>
+        <p:spPr>
+          <a:xfrm>
+            <a:off x="0" y="0"/>
+            <a:ext cx="12188952" cy="109728"/>
+          </a:xfrm>
+          <a:prstGeom prst="rect">
+            <a:avLst/>
+          </a:prstGeom>
+          <a:solidFill>
+            <a:srgbClr val="3EB7DB"/>
+          </a:solidFill>
+          <a:ln>
+            <a:noFill/>
+          </a:ln>
+        </p:spPr>
+        <p:style>
+          <a:lnRef idx="1">
+            <a:schemeClr val="accent1"/>
+          </a:lnRef>
+          <a:fillRef idx="3">
+            <a:schemeClr val="accent1"/>
+          </a:fillRef>
+          <a:effectRef idx="2">
+            <a:schemeClr val="accent1"/>
+          </a:effectRef>
+          <a:fontRef idx="minor">
+            <a:schemeClr val="lt1"/>
+          </a:fontRef>
+        </p:style>
+        <p:txBody>
+          <a:bodyPr rtlCol="0" anchor="ctr"/>
+          <a:lstStyle/>
+          <a:p>
+            <a:pPr algn="ctr"/>
+          </a:p>
+        </p:txBody>
+      </p:sp>
+      <p:sp>
+        <p:nvSpPr>
+          <p:cNvPr id="4" name="Oval 3"/>
+          <p:cNvSpPr/>
+          <p:nvPr/>
+        </p:nvSpPr>
+        <p:spPr>
+          <a:xfrm>
+            <a:off x="7772400" y="4389120"/>
+            <a:ext cx="3657600" cy="3657600"/>
+          </a:xfrm>
+          <a:prstGeom prst="ellipse">
+            <a:avLst/>
+          </a:prstGeom>
+          <a:solidFill>
+            <a:srgbClr val="3EB7DB"/>
+          </a:solidFill>
+          <a:ln>
+            <a:noFill/>
+          </a:ln>
+        </p:spPr>
+        <p:style>
+          <a:lnRef idx="1">
+            <a:schemeClr val="accent1"/>
+          </a:lnRef>
+          <a:fillRef idx="3">
+            <a:schemeClr val="accent1"/>
+          </a:fillRef>
+          <a:effectRef idx="2">
+            <a:schemeClr val="accent1"/>
+          </a:effectRef>
+          <a:fontRef idx="minor">
+            <a:schemeClr val="lt1"/>
+          </a:fontRef>
+        </p:style>
+        <p:txBody>
+          <a:bodyPr rtlCol="0" anchor="ctr"/>
+          <a:lstStyle/>
+          <a:p>
+            <a:pPr algn="ctr"/>
+          </a:p>
+        </p:txBody>
+      </p:sp>
+      <p:sp>
+        <p:nvSpPr>
+          <p:cNvPr id="3" name="Oval 2"/>
+          <p:cNvSpPr/>
+          <p:nvPr/>
+        </p:nvSpPr>
+        <p:spPr>
+          <a:xfrm>
+            <a:off x="-1097280" y="-914400"/>
+            <a:ext cx="3657600" cy="3657600"/>
+          </a:xfrm>
+          <a:prstGeom prst="ellipse">
+            <a:avLst/>
+          </a:prstGeom>
+          <a:solidFill>
+            <a:srgbClr val="336DD9"/>
+          </a:solidFill>
+          <a:ln>
+            <a:noFill/>
+          </a:ln>
+        </p:spPr>
+        <p:style>
+          <a:lnRef idx="1">
+            <a:schemeClr val="accent1"/>
+          </a:lnRef>
+          <a:fillRef idx="3">
+            <a:schemeClr val="accent1"/>
+          </a:fillRef>
+          <a:effectRef idx="2">
+            <a:schemeClr val="accent1"/>
+          </a:effectRef>
+          <a:fontRef idx="minor">
+            <a:schemeClr val="lt1"/>
+          </a:fontRef>
+        </p:style>
+        <p:txBody>
+          <a:bodyPr rtlCol="0" anchor="ctr"/>
+          <a:lstStyle/>
+          <a:p>
+            <a:pPr algn="ctr"/>
+          </a:p>
+        </p:txBody>
+      </p:sp>
+      <p:sp>
+        <p:nvSpPr>
           <p:cNvPr id="2" name="Title 1"/>
           <p:cNvSpPr>
             <a:spLocks noGrp="1"/>
@@ -4782,9 +6552,20 @@
           <a:lstStyle/>
           <a:p>
             <a:pPr>
-              <a:defRPr sz="3400"/>
+              <a:defRPr sz="3400" b="1">
+                <a:solidFill>
+                  <a:srgbClr val="ECF1FF"/>
+                </a:solidFill>
+                <a:latin typeface="Calibri"/>
+              </a:defRPr>
             </a:pPr>
             <a:r>
+              <a:rPr sz="3400" b="1">
+                <a:solidFill>
+                  <a:srgbClr val="ECF1FF"/>
+                </a:solidFill>
+                <a:latin typeface="Calibri"/>
+              </a:rPr>
               <a:t>Confusion Matrix Comparison</a:t>
             </a:r>
           </a:p>
@@ -4792,7 +6573,7 @@
       </p:sp>
       <p:pic>
         <p:nvPicPr>
-          <p:cNvPr id="3" name="Picture 2" descr="rf_3class_confusion_matrix.png"/>
+          <p:cNvPr id="6" name="Picture 5" descr="rf_3class_confusion_matrix.png"/>
           <p:cNvPicPr>
             <a:picLocks noChangeAspect="1"/>
           </p:cNvPicPr>
@@ -4814,9 +6595,52 @@
           </a:prstGeom>
         </p:spPr>
       </p:pic>
+      <p:sp>
+        <p:nvSpPr>
+          <p:cNvPr id="7" name="Rectangle 6"/>
+          <p:cNvSpPr/>
+          <p:nvPr/>
+        </p:nvSpPr>
+        <p:spPr>
+          <a:xfrm>
+            <a:off x="384048" y="1725141"/>
+            <a:ext cx="4169664" cy="3224836"/>
+          </a:xfrm>
+          <a:prstGeom prst="rect">
+            <a:avLst/>
+          </a:prstGeom>
+          <a:noFill/>
+          <a:ln w="22860">
+            <a:solidFill>
+              <a:srgbClr val="3EB7DB"/>
+            </a:solidFill>
+          </a:ln>
+        </p:spPr>
+        <p:style>
+          <a:lnRef idx="1">
+            <a:schemeClr val="accent1"/>
+          </a:lnRef>
+          <a:fillRef idx="3">
+            <a:schemeClr val="accent1"/>
+          </a:fillRef>
+          <a:effectRef idx="2">
+            <a:schemeClr val="accent1"/>
+          </a:effectRef>
+          <a:fontRef idx="minor">
+            <a:schemeClr val="lt1"/>
+          </a:fontRef>
+        </p:style>
+        <p:txBody>
+          <a:bodyPr rtlCol="0" anchor="ctr"/>
+          <a:lstStyle/>
+          <a:p>
+            <a:pPr algn="ctr"/>
+          </a:p>
+        </p:txBody>
+      </p:sp>
       <p:pic>
         <p:nvPicPr>
-          <p:cNvPr id="4" name="Picture 3" descr="cnn_3class_confusion_matrix.png"/>
+          <p:cNvPr id="8" name="Picture 7" descr="cnn_3class_confusion_matrix.png"/>
           <p:cNvPicPr>
             <a:picLocks noChangeAspect="1"/>
           </p:cNvPicPr>
@@ -4840,7 +6664,50 @@
       </p:pic>
       <p:sp>
         <p:nvSpPr>
-          <p:cNvPr id="5" name="TextBox 4"/>
+          <p:cNvPr id="9" name="Rectangle 8"/>
+          <p:cNvSpPr/>
+          <p:nvPr/>
+        </p:nvSpPr>
+        <p:spPr>
+          <a:xfrm>
+            <a:off x="4590288" y="1588008"/>
+            <a:ext cx="4169664" cy="3499104"/>
+          </a:xfrm>
+          <a:prstGeom prst="rect">
+            <a:avLst/>
+          </a:prstGeom>
+          <a:noFill/>
+          <a:ln w="22860">
+            <a:solidFill>
+              <a:srgbClr val="3EB7DB"/>
+            </a:solidFill>
+          </a:ln>
+        </p:spPr>
+        <p:style>
+          <a:lnRef idx="1">
+            <a:schemeClr val="accent1"/>
+          </a:lnRef>
+          <a:fillRef idx="3">
+            <a:schemeClr val="accent1"/>
+          </a:fillRef>
+          <a:effectRef idx="2">
+            <a:schemeClr val="accent1"/>
+          </a:effectRef>
+          <a:fontRef idx="minor">
+            <a:schemeClr val="lt1"/>
+          </a:fontRef>
+        </p:style>
+        <p:txBody>
+          <a:bodyPr rtlCol="0" anchor="ctr"/>
+          <a:lstStyle/>
+          <a:p>
+            <a:pPr algn="ctr"/>
+          </a:p>
+        </p:txBody>
+      </p:sp>
+      <p:sp>
+        <p:nvSpPr>
+          <p:cNvPr id="10" name="TextBox 9"/>
           <p:cNvSpPr txBox="1"/>
           <p:nvPr/>
         </p:nvSpPr>
@@ -4860,10 +6727,21 @@
           </a:bodyPr>
           <a:lstStyle/>
           <a:p>
-            <a:pPr>
-              <a:defRPr sz="1400"/>
+            <a:pPr algn="ctr">
+              <a:defRPr sz="1400" b="0">
+                <a:solidFill>
+                  <a:srgbClr val="B9C4E2"/>
+                </a:solidFill>
+                <a:latin typeface="Calibri"/>
+              </a:defRPr>
             </a:pPr>
             <a:r>
+              <a:rPr sz="1400" b="0">
+                <a:solidFill>
+                  <a:srgbClr val="B9C4E2"/>
+                </a:solidFill>
+                <a:latin typeface="Calibri"/>
+              </a:rPr>
               <a:t>Random Forest: tighter class separation</a:t>
             </a:r>
           </a:p>
@@ -4871,7 +6749,7 @@
       </p:sp>
       <p:sp>
         <p:nvSpPr>
-          <p:cNvPr id="6" name="TextBox 5"/>
+          <p:cNvPr id="11" name="TextBox 10"/>
           <p:cNvSpPr txBox="1"/>
           <p:nvPr/>
         </p:nvSpPr>
@@ -4891,10 +6769,21 @@
           </a:bodyPr>
           <a:lstStyle/>
           <a:p>
-            <a:pPr>
-              <a:defRPr sz="1400"/>
+            <a:pPr algn="ctr">
+              <a:defRPr sz="1400" b="0">
+                <a:solidFill>
+                  <a:srgbClr val="B9C4E2"/>
+                </a:solidFill>
+                <a:latin typeface="Calibri"/>
+              </a:defRPr>
             </a:pPr>
             <a:r>
+              <a:rPr sz="1400" b="0">
+                <a:solidFill>
+                  <a:srgbClr val="B9C4E2"/>
+                </a:solidFill>
+                <a:latin typeface="Calibri"/>
+              </a:rPr>
               <a:t>1D-CNN: greater off-diagonal confusion</a:t>
             </a:r>
           </a:p>
@@ -4911,6 +6800,14 @@
 <file path=ppt/slides/slide8.xml><?xml version="1.0" encoding="utf-8"?>
 <p:sld xmlns:a="http://schemas.openxmlformats.org/drawingml/2006/main" xmlns:p="http://schemas.openxmlformats.org/presentationml/2006/main" xmlns:r="http://schemas.openxmlformats.org/officeDocument/2006/relationships">
   <p:cSld>
+    <p:bg>
+      <p:bgPr>
+        <a:solidFill>
+          <a:srgbClr val="0B1020"/>
+        </a:solidFill>
+        <a:effectLst/>
+      </p:bgPr>
+    </p:bg>
     <p:spTree>
       <p:nvGrpSpPr>
         <p:cNvPr id="1" name=""/>
@@ -4920,6 +6817,135 @@
       <p:grpSpPr/>
       <p:sp>
         <p:nvSpPr>
+          <p:cNvPr id="5" name="Rectangle 4"/>
+          <p:cNvSpPr/>
+          <p:nvPr/>
+        </p:nvSpPr>
+        <p:spPr>
+          <a:xfrm>
+            <a:off x="0" y="0"/>
+            <a:ext cx="12188952" cy="109728"/>
+          </a:xfrm>
+          <a:prstGeom prst="rect">
+            <a:avLst/>
+          </a:prstGeom>
+          <a:solidFill>
+            <a:srgbClr val="3EB7DB"/>
+          </a:solidFill>
+          <a:ln>
+            <a:noFill/>
+          </a:ln>
+        </p:spPr>
+        <p:style>
+          <a:lnRef idx="1">
+            <a:schemeClr val="accent1"/>
+          </a:lnRef>
+          <a:fillRef idx="3">
+            <a:schemeClr val="accent1"/>
+          </a:fillRef>
+          <a:effectRef idx="2">
+            <a:schemeClr val="accent1"/>
+          </a:effectRef>
+          <a:fontRef idx="minor">
+            <a:schemeClr val="lt1"/>
+          </a:fontRef>
+        </p:style>
+        <p:txBody>
+          <a:bodyPr rtlCol="0" anchor="ctr"/>
+          <a:lstStyle/>
+          <a:p>
+            <a:pPr algn="ctr"/>
+          </a:p>
+        </p:txBody>
+      </p:sp>
+      <p:sp>
+        <p:nvSpPr>
+          <p:cNvPr id="4" name="Oval 3"/>
+          <p:cNvSpPr/>
+          <p:nvPr/>
+        </p:nvSpPr>
+        <p:spPr>
+          <a:xfrm>
+            <a:off x="7772400" y="4389120"/>
+            <a:ext cx="3657600" cy="3657600"/>
+          </a:xfrm>
+          <a:prstGeom prst="ellipse">
+            <a:avLst/>
+          </a:prstGeom>
+          <a:solidFill>
+            <a:srgbClr val="3EB7DB"/>
+          </a:solidFill>
+          <a:ln>
+            <a:noFill/>
+          </a:ln>
+        </p:spPr>
+        <p:style>
+          <a:lnRef idx="1">
+            <a:schemeClr val="accent1"/>
+          </a:lnRef>
+          <a:fillRef idx="3">
+            <a:schemeClr val="accent1"/>
+          </a:fillRef>
+          <a:effectRef idx="2">
+            <a:schemeClr val="accent1"/>
+          </a:effectRef>
+          <a:fontRef idx="minor">
+            <a:schemeClr val="lt1"/>
+          </a:fontRef>
+        </p:style>
+        <p:txBody>
+          <a:bodyPr rtlCol="0" anchor="ctr"/>
+          <a:lstStyle/>
+          <a:p>
+            <a:pPr algn="ctr"/>
+          </a:p>
+        </p:txBody>
+      </p:sp>
+      <p:sp>
+        <p:nvSpPr>
+          <p:cNvPr id="3" name="Oval 2"/>
+          <p:cNvSpPr/>
+          <p:nvPr/>
+        </p:nvSpPr>
+        <p:spPr>
+          <a:xfrm>
+            <a:off x="-1097280" y="-914400"/>
+            <a:ext cx="3657600" cy="3657600"/>
+          </a:xfrm>
+          <a:prstGeom prst="ellipse">
+            <a:avLst/>
+          </a:prstGeom>
+          <a:solidFill>
+            <a:srgbClr val="336DD9"/>
+          </a:solidFill>
+          <a:ln>
+            <a:noFill/>
+          </a:ln>
+        </p:spPr>
+        <p:style>
+          <a:lnRef idx="1">
+            <a:schemeClr val="accent1"/>
+          </a:lnRef>
+          <a:fillRef idx="3">
+            <a:schemeClr val="accent1"/>
+          </a:fillRef>
+          <a:effectRef idx="2">
+            <a:schemeClr val="accent1"/>
+          </a:effectRef>
+          <a:fontRef idx="minor">
+            <a:schemeClr val="lt1"/>
+          </a:fontRef>
+        </p:style>
+        <p:txBody>
+          <a:bodyPr rtlCol="0" anchor="ctr"/>
+          <a:lstStyle/>
+          <a:p>
+            <a:pPr algn="ctr"/>
+          </a:p>
+        </p:txBody>
+      </p:sp>
+      <p:sp>
+        <p:nvSpPr>
           <p:cNvPr id="2" name="Title 1"/>
           <p:cNvSpPr>
             <a:spLocks noGrp="1"/>
@@ -4934,9 +6960,20 @@
           <a:lstStyle/>
           <a:p>
             <a:pPr>
-              <a:defRPr sz="3400"/>
+              <a:defRPr sz="3400" b="1">
+                <a:solidFill>
+                  <a:srgbClr val="ECF1FF"/>
+                </a:solidFill>
+                <a:latin typeface="Calibri"/>
+              </a:defRPr>
             </a:pPr>
             <a:r>
+              <a:rPr sz="3400" b="1">
+                <a:solidFill>
+                  <a:srgbClr val="ECF1FF"/>
+                </a:solidFill>
+                <a:latin typeface="Calibri"/>
+              </a:rPr>
               <a:t>Interpretability and Alert Dynamics</a:t>
             </a:r>
           </a:p>
@@ -4944,7 +6981,7 @@
       </p:sp>
       <p:pic>
         <p:nvPicPr>
-          <p:cNvPr id="3" name="Picture 2" descr="rf_3class_feature_importance.png"/>
+          <p:cNvPr id="6" name="Picture 5" descr="rf_3class_feature_importance.png"/>
           <p:cNvPicPr>
             <a:picLocks noChangeAspect="1"/>
           </p:cNvPicPr>
@@ -4966,9 +7003,52 @@
           </a:prstGeom>
         </p:spPr>
       </p:pic>
+      <p:sp>
+        <p:nvSpPr>
+          <p:cNvPr id="7" name="Rectangle 6"/>
+          <p:cNvSpPr/>
+          <p:nvPr/>
+        </p:nvSpPr>
+        <p:spPr>
+          <a:xfrm>
+            <a:off x="384048" y="1255437"/>
+            <a:ext cx="4169664" cy="4164245"/>
+          </a:xfrm>
+          <a:prstGeom prst="rect">
+            <a:avLst/>
+          </a:prstGeom>
+          <a:noFill/>
+          <a:ln w="22860">
+            <a:solidFill>
+              <a:srgbClr val="3EB7DB"/>
+            </a:solidFill>
+          </a:ln>
+        </p:spPr>
+        <p:style>
+          <a:lnRef idx="1">
+            <a:schemeClr val="accent1"/>
+          </a:lnRef>
+          <a:fillRef idx="3">
+            <a:schemeClr val="accent1"/>
+          </a:fillRef>
+          <a:effectRef idx="2">
+            <a:schemeClr val="accent1"/>
+          </a:effectRef>
+          <a:fontRef idx="minor">
+            <a:schemeClr val="lt1"/>
+          </a:fontRef>
+        </p:style>
+        <p:txBody>
+          <a:bodyPr rtlCol="0" anchor="ctr"/>
+          <a:lstStyle/>
+          <a:p>
+            <a:pPr algn="ctr"/>
+          </a:p>
+        </p:txBody>
+      </p:sp>
       <p:pic>
         <p:nvPicPr>
-          <p:cNvPr id="4" name="Picture 3" descr="blockF_alert_timeline.png"/>
+          <p:cNvPr id="8" name="Picture 7" descr="blockF_alert_timeline.png"/>
           <p:cNvPicPr>
             <a:picLocks noChangeAspect="1"/>
           </p:cNvPicPr>
@@ -4992,7 +7072,50 @@
       </p:pic>
       <p:sp>
         <p:nvSpPr>
-          <p:cNvPr id="5" name="TextBox 4"/>
+          <p:cNvPr id="9" name="Rectangle 8"/>
+          <p:cNvSpPr/>
+          <p:nvPr/>
+        </p:nvSpPr>
+        <p:spPr>
+          <a:xfrm>
+            <a:off x="4590288" y="1274676"/>
+            <a:ext cx="4169664" cy="4125766"/>
+          </a:xfrm>
+          <a:prstGeom prst="rect">
+            <a:avLst/>
+          </a:prstGeom>
+          <a:noFill/>
+          <a:ln w="22860">
+            <a:solidFill>
+              <a:srgbClr val="3EB7DB"/>
+            </a:solidFill>
+          </a:ln>
+        </p:spPr>
+        <p:style>
+          <a:lnRef idx="1">
+            <a:schemeClr val="accent1"/>
+          </a:lnRef>
+          <a:fillRef idx="3">
+            <a:schemeClr val="accent1"/>
+          </a:fillRef>
+          <a:effectRef idx="2">
+            <a:schemeClr val="accent1"/>
+          </a:effectRef>
+          <a:fontRef idx="minor">
+            <a:schemeClr val="lt1"/>
+          </a:fontRef>
+        </p:style>
+        <p:txBody>
+          <a:bodyPr rtlCol="0" anchor="ctr"/>
+          <a:lstStyle/>
+          <a:p>
+            <a:pPr algn="ctr"/>
+          </a:p>
+        </p:txBody>
+      </p:sp>
+      <p:sp>
+        <p:nvSpPr>
+          <p:cNvPr id="10" name="TextBox 9"/>
           <p:cNvSpPr txBox="1"/>
           <p:nvPr/>
         </p:nvSpPr>
@@ -5012,10 +7135,21 @@
           </a:bodyPr>
           <a:lstStyle/>
           <a:p>
-            <a:pPr>
-              <a:defRPr sz="1400"/>
+            <a:pPr algn="ctr">
+              <a:defRPr sz="1400" b="0">
+                <a:solidFill>
+                  <a:srgbClr val="B9C4E2"/>
+                </a:solidFill>
+                <a:latin typeface="Calibri"/>
+              </a:defRPr>
             </a:pPr>
             <a:r>
+              <a:rPr sz="1400" b="0">
+                <a:solidFill>
+                  <a:srgbClr val="B9C4E2"/>
+                </a:solidFill>
+                <a:latin typeface="Calibri"/>
+              </a:rPr>
               <a:t>RF feature/domain importance</a:t>
             </a:r>
           </a:p>
@@ -5023,7 +7157,7 @@
       </p:sp>
       <p:sp>
         <p:nvSpPr>
-          <p:cNvPr id="6" name="TextBox 5"/>
+          <p:cNvPr id="11" name="TextBox 10"/>
           <p:cNvSpPr txBox="1"/>
           <p:nvPr/>
         </p:nvSpPr>
@@ -5043,10 +7177,21 @@
           </a:bodyPr>
           <a:lstStyle/>
           <a:p>
-            <a:pPr>
-              <a:defRPr sz="1400"/>
+            <a:pPr algn="ctr">
+              <a:defRPr sz="1400" b="0">
+                <a:solidFill>
+                  <a:srgbClr val="B9C4E2"/>
+                </a:solidFill>
+                <a:latin typeface="Calibri"/>
+              </a:defRPr>
             </a:pPr>
             <a:r>
+              <a:rPr sz="1400" b="0">
+                <a:solidFill>
+                  <a:srgbClr val="B9C4E2"/>
+                </a:solidFill>
+                <a:latin typeface="Calibri"/>
+              </a:rPr>
               <a:t>Temporal alert timeline after smoothing</a:t>
             </a:r>
           </a:p>
@@ -5063,6 +7208,14 @@
 <file path=ppt/slides/slide9.xml><?xml version="1.0" encoding="utf-8"?>
 <p:sld xmlns:a="http://schemas.openxmlformats.org/drawingml/2006/main" xmlns:p="http://schemas.openxmlformats.org/presentationml/2006/main" xmlns:r="http://schemas.openxmlformats.org/officeDocument/2006/relationships">
   <p:cSld>
+    <p:bg>
+      <p:bgPr>
+        <a:solidFill>
+          <a:srgbClr val="0B1020"/>
+        </a:solidFill>
+        <a:effectLst/>
+      </p:bgPr>
+    </p:bg>
     <p:spTree>
       <p:nvGrpSpPr>
         <p:cNvPr id="1" name=""/>
@@ -5072,6 +7225,135 @@
       <p:grpSpPr/>
       <p:sp>
         <p:nvSpPr>
+          <p:cNvPr id="6" name="Rectangle 5"/>
+          <p:cNvSpPr/>
+          <p:nvPr/>
+        </p:nvSpPr>
+        <p:spPr>
+          <a:xfrm>
+            <a:off x="0" y="0"/>
+            <a:ext cx="12188952" cy="109728"/>
+          </a:xfrm>
+          <a:prstGeom prst="rect">
+            <a:avLst/>
+          </a:prstGeom>
+          <a:solidFill>
+            <a:srgbClr val="3EB7DB"/>
+          </a:solidFill>
+          <a:ln>
+            <a:noFill/>
+          </a:ln>
+        </p:spPr>
+        <p:style>
+          <a:lnRef idx="1">
+            <a:schemeClr val="accent1"/>
+          </a:lnRef>
+          <a:fillRef idx="3">
+            <a:schemeClr val="accent1"/>
+          </a:fillRef>
+          <a:effectRef idx="2">
+            <a:schemeClr val="accent1"/>
+          </a:effectRef>
+          <a:fontRef idx="minor">
+            <a:schemeClr val="lt1"/>
+          </a:fontRef>
+        </p:style>
+        <p:txBody>
+          <a:bodyPr rtlCol="0" anchor="ctr"/>
+          <a:lstStyle/>
+          <a:p>
+            <a:pPr algn="ctr"/>
+          </a:p>
+        </p:txBody>
+      </p:sp>
+      <p:sp>
+        <p:nvSpPr>
+          <p:cNvPr id="5" name="Oval 4"/>
+          <p:cNvSpPr/>
+          <p:nvPr/>
+        </p:nvSpPr>
+        <p:spPr>
+          <a:xfrm>
+            <a:off x="7772400" y="4389120"/>
+            <a:ext cx="3657600" cy="3657600"/>
+          </a:xfrm>
+          <a:prstGeom prst="ellipse">
+            <a:avLst/>
+          </a:prstGeom>
+          <a:solidFill>
+            <a:srgbClr val="3EB7DB"/>
+          </a:solidFill>
+          <a:ln>
+            <a:noFill/>
+          </a:ln>
+        </p:spPr>
+        <p:style>
+          <a:lnRef idx="1">
+            <a:schemeClr val="accent1"/>
+          </a:lnRef>
+          <a:fillRef idx="3">
+            <a:schemeClr val="accent1"/>
+          </a:fillRef>
+          <a:effectRef idx="2">
+            <a:schemeClr val="accent1"/>
+          </a:effectRef>
+          <a:fontRef idx="minor">
+            <a:schemeClr val="lt1"/>
+          </a:fontRef>
+        </p:style>
+        <p:txBody>
+          <a:bodyPr rtlCol="0" anchor="ctr"/>
+          <a:lstStyle/>
+          <a:p>
+            <a:pPr algn="ctr"/>
+          </a:p>
+        </p:txBody>
+      </p:sp>
+      <p:sp>
+        <p:nvSpPr>
+          <p:cNvPr id="4" name="Oval 3"/>
+          <p:cNvSpPr/>
+          <p:nvPr/>
+        </p:nvSpPr>
+        <p:spPr>
+          <a:xfrm>
+            <a:off x="-1097280" y="-914400"/>
+            <a:ext cx="3657600" cy="3657600"/>
+          </a:xfrm>
+          <a:prstGeom prst="ellipse">
+            <a:avLst/>
+          </a:prstGeom>
+          <a:solidFill>
+            <a:srgbClr val="336DD9"/>
+          </a:solidFill>
+          <a:ln>
+            <a:noFill/>
+          </a:ln>
+        </p:spPr>
+        <p:style>
+          <a:lnRef idx="1">
+            <a:schemeClr val="accent1"/>
+          </a:lnRef>
+          <a:fillRef idx="3">
+            <a:schemeClr val="accent1"/>
+          </a:fillRef>
+          <a:effectRef idx="2">
+            <a:schemeClr val="accent1"/>
+          </a:effectRef>
+          <a:fontRef idx="minor">
+            <a:schemeClr val="lt1"/>
+          </a:fontRef>
+        </p:style>
+        <p:txBody>
+          <a:bodyPr rtlCol="0" anchor="ctr"/>
+          <a:lstStyle/>
+          <a:p>
+            <a:pPr algn="ctr"/>
+          </a:p>
+        </p:txBody>
+      </p:sp>
+      <p:sp>
+        <p:nvSpPr>
           <p:cNvPr id="2" name="Title 1"/>
           <p:cNvSpPr>
             <a:spLocks noGrp="1"/>
@@ -5086,9 +7368,20 @@
           <a:lstStyle/>
           <a:p>
             <a:pPr>
-              <a:defRPr sz="3400"/>
+              <a:defRPr sz="3400" b="1">
+                <a:solidFill>
+                  <a:srgbClr val="ECF1FF"/>
+                </a:solidFill>
+                <a:latin typeface="Calibri"/>
+              </a:defRPr>
             </a:pPr>
             <a:r>
+              <a:rPr sz="3400" b="1">
+                <a:solidFill>
+                  <a:srgbClr val="ECF1FF"/>
+                </a:solidFill>
+                <a:latin typeface="Calibri"/>
+              </a:rPr>
               <a:t>Conclusion</a:t>
             </a:r>
           </a:p>
@@ -5110,27 +7403,103 @@
           <a:lstStyle/>
           <a:p>
             <a:pPr>
-              <a:defRPr sz="2000"/>
+              <a:defRPr sz="2000" b="0">
+                <a:solidFill>
+                  <a:srgbClr val="ECF1FF"/>
+                </a:solidFill>
+                <a:latin typeface="Calibri"/>
+              </a:defRPr>
             </a:pPr>
             <a:r>
+              <a:rPr sz="2000" b="0">
+                <a:solidFill>
+                  <a:srgbClr val="ECF1FF"/>
+                </a:solidFill>
+                <a:latin typeface="Calibri"/>
+              </a:rPr>
               <a:t>Under tested conditions, Random Forest is the more suitable transparent baseline.</a:t>
             </a:r>
           </a:p>
           <a:p>
             <a:pPr>
-              <a:defRPr sz="2000"/>
+              <a:defRPr sz="2000" b="0">
+                <a:solidFill>
+                  <a:srgbClr val="ECF1FF"/>
+                </a:solidFill>
+                <a:latin typeface="Calibri"/>
+              </a:defRPr>
             </a:pPr>
             <a:r>
+              <a:rPr sz="2000" b="0">
+                <a:solidFill>
+                  <a:srgbClr val="ECF1FF"/>
+                </a:solidFill>
+                <a:latin typeface="Calibri"/>
+              </a:rPr>
               <a:t>This does not imply deep learning is always worse in CTG.</a:t>
             </a:r>
           </a:p>
           <a:p>
             <a:pPr>
-              <a:defRPr sz="2000"/>
+              <a:defRPr sz="2000" b="0">
+                <a:solidFill>
+                  <a:srgbClr val="ECF1FF"/>
+                </a:solidFill>
+                <a:latin typeface="Calibri"/>
+              </a:defRPr>
             </a:pPr>
             <a:r>
+              <a:rPr sz="2000" b="0">
+                <a:solidFill>
+                  <a:srgbClr val="ECF1FF"/>
+                </a:solidFill>
+                <a:latin typeface="Calibri"/>
+              </a:rPr>
               <a:t>The contribution is an auditable benchmark reference for next-stage validation.</a:t>
             </a:r>
+          </a:p>
+        </p:txBody>
+      </p:sp>
+      <p:sp>
+        <p:nvSpPr>
+          <p:cNvPr id="7" name="Rectangle 6"/>
+          <p:cNvSpPr/>
+          <p:nvPr/>
+        </p:nvSpPr>
+        <p:spPr>
+          <a:xfrm>
+            <a:off x="822960" y="1234440"/>
+            <a:ext cx="2011680" cy="45720"/>
+          </a:xfrm>
+          <a:prstGeom prst="rect">
+            <a:avLst/>
+          </a:prstGeom>
+          <a:solidFill>
+            <a:srgbClr val="3EB7DB"/>
+          </a:solidFill>
+          <a:ln>
+            <a:noFill/>
+          </a:ln>
+        </p:spPr>
+        <p:style>
+          <a:lnRef idx="1">
+            <a:schemeClr val="accent1"/>
+          </a:lnRef>
+          <a:fillRef idx="3">
+            <a:schemeClr val="accent1"/>
+          </a:fillRef>
+          <a:effectRef idx="2">
+            <a:schemeClr val="accent1"/>
+          </a:effectRef>
+          <a:fontRef idx="minor">
+            <a:schemeClr val="lt1"/>
+          </a:fontRef>
+        </p:style>
+        <p:txBody>
+          <a:bodyPr rtlCol="0" anchor="ctr"/>
+          <a:lstStyle/>
+          <a:p>
+            <a:pPr algn="ctr"/>
           </a:p>
         </p:txBody>
       </p:sp>

</xml_diff>